<commit_message>
Shorten Case Study 2 enablement cadence: Reverse shadow M6–M9, Auto M12–M15
Compress phased rollout map and align autonomy uplift / exec quality gates
to M15. Regenerate Case Study 2 executive PPTX and PDF.

Co-authored-by: gauravch86 <gauravch86@users.noreply.github.com>
</commit_message>
<xml_diff>
--- a/case-study-2-ao-offering-executive.pptx
+++ b/case-study-2-ao-offering-executive.pptx
@@ -946,6 +946,12 @@
           <a:p>
             <a:r>
               <a:t>• Pass-gate = explicit go/no-go criteria before expanding scope or geography</a:t>
+            </a:r>
+          </a:p>
+          <a:p/>
+          <a:p>
+            <a:r>
+              <a:t>PHASED ROLLOUT (UPDATED): M0–M3 train · M3–M6 forward shadow · M6–M9 reverse shadow / HITL / region kit · M12–M15 auto classes expand / Nth-logo / reuse proof. M9–M12 is HITL stabilize before auto expand.</a:t>
             </a:r>
           </a:p>
         </p:txBody>
@@ -7069,7 +7075,7 @@
                 </a:solidFill>
                 <a:latin typeface="Calibri"/>
               </a:rPr>
-              <a:t>•  Executive quality gates at month 3 / 12 / 18</a:t>
+              <a:t>•  Executive quality gates at month 3 / 12 / 15</a:t>
             </a:r>
           </a:p>
         </p:txBody>

</xml_diff>

<commit_message>
Remove on-slide timers and tighten Case Study 1 dual P&L story
Strip SLIDE BUDGET / MOVE ON overlays from both executive decks so content
regains slide space. Reframe CS1 around SPM ownership of new revenue and
margin/EBIT, discount-for-scope trades, top-10-account win/loss, and clearer
coverage of packaging, guardrails, invest ROI, alignment, and feedback metrics.

Co-authored-by: gauravch86 <gauravch86@users.noreply.github.com>
</commit_message>
<xml_diff>
--- a/case-study-2-ao-offering-executive.pptx
+++ b/case-study-2-ao-offering-executive.pptx
@@ -534,12 +534,6 @@
               <a:t>GLOSSARY: KPI · OKR · TCO · SLA · CPI · NPS · 3PP / third-party products.</a:t>
             </a:r>
           </a:p>
-          <a:p/>
-          <a:p>
-            <a:r>
-              <a:t>ON-SLIDE TIMER: Budget 1:15 for this slide. Gold bar counts down in Slideshow; red MOVE ON appears when budget ends (does not auto-advance). Prefer presenter-timer.html on a second screen for a live stopwatch that records actual seconds per slide. By end of this slide you should be at ~1:15 of 10:00 (~8:45 remaining).</a:t>
-            </a:r>
-          </a:p>
         </p:txBody>
       </p:sp>
       <p:sp>
@@ -632,12 +626,6 @@
               <a:t>GLOSSARY: MTTR = mean time to restore · SDM = Service Delivery Manager · TCO = total cost of ownership.</a:t>
             </a:r>
           </a:p>
-          <a:p/>
-          <a:p>
-            <a:r>
-              <a:t>ON-SLIDE TIMER: Budget 1:15 for this slide. Gold bar counts down in Slideshow; red MOVE ON appears when budget ends (does not auto-advance). Prefer presenter-timer.html on a second screen for a live stopwatch that records actual seconds per slide. By end of this slide you should be at ~2:30 of 10:00 (~7:30 remaining).</a:t>
-            </a:r>
-          </a:p>
         </p:txBody>
       </p:sp>
       <p:sp>
@@ -719,12 +707,6 @@
               <a:t>GLOSSARY: SPOG = single pane of glass · HITL = human-in-the-loop · Shadow mode · Known error.</a:t>
             </a:r>
           </a:p>
-          <a:p/>
-          <a:p>
-            <a:r>
-              <a:t>ON-SLIDE TIMER: Budget 1:15 for this slide. Gold bar counts down in Slideshow; red MOVE ON appears when budget ends (does not auto-advance). Prefer presenter-timer.html on a second screen for a live stopwatch that records actual seconds per slide. By end of this slide you should be at ~3:45 of 10:00 (~6:15 remaining).</a:t>
-            </a:r>
-          </a:p>
         </p:txBody>
       </p:sp>
       <p:sp>
@@ -806,12 +788,6 @@
               <a:t>GLOSSARY: CPI · Soft-ramp · Top offender · P0/P1 · Credit.</a:t>
             </a:r>
           </a:p>
-          <a:p/>
-          <a:p>
-            <a:r>
-              <a:t>ON-SLIDE TIMER: Budget 1:15 for this slide. Gold bar counts down in Slideshow; red MOVE ON appears when budget ends (does not auto-advance). Prefer presenter-timer.html on a second screen for a live stopwatch that records actual seconds per slide. By end of this slide you should be at ~5:00 of 10:00 (~5:00 remaining).</a:t>
-            </a:r>
-          </a:p>
         </p:txBody>
       </p:sp>
       <p:sp>
@@ -893,12 +869,6 @@
               <a:t>GLOSSARY: Adapter · Reuse library · IP = intellectual property.</a:t>
             </a:r>
           </a:p>
-          <a:p/>
-          <a:p>
-            <a:r>
-              <a:t>ON-SLIDE TIMER: Budget 1:00 for this slide. Gold bar counts down in Slideshow; red MOVE ON appears when budget ends (does not auto-advance). Prefer presenter-timer.html on a second screen for a live stopwatch that records actual seconds per slide. By end of this slide you should be at ~6:00 of 10:00 (~4:00 remaining).</a:t>
-            </a:r>
-          </a:p>
         </p:txBody>
       </p:sp>
       <p:sp>
@@ -990,12 +960,6 @@
               <a:t>GLOSSARY: Forward/Reverse shadow · HITL · Pass-gate · Nth logo.</a:t>
             </a:r>
           </a:p>
-          <a:p/>
-          <a:p>
-            <a:r>
-              <a:t>ON-SLIDE TIMER: Budget 1:15 for this slide. Gold bar counts down in Slideshow; red MOVE ON appears when budget ends (does not auto-advance). Prefer presenter-timer.html on a second screen for a live stopwatch that records actual seconds per slide. By end of this slide you should be at ~7:15 of 10:00 (~2:45 remaining).</a:t>
-            </a:r>
-          </a:p>
         </p:txBody>
       </p:sp>
       <p:sp>
@@ -1077,12 +1041,6 @@
               <a:t>GLOSSARY: FTE · B · X · EBIT · Site-mix · Penalty lot · Earn-back.</a:t>
             </a:r>
           </a:p>
-          <a:p/>
-          <a:p>
-            <a:r>
-              <a:t>ON-SLIDE TIMER: Budget 1:30 for this slide. Gold bar counts down in Slideshow; red MOVE ON appears when budget ends (does not auto-advance). Prefer presenter-timer.html on a second screen for a live stopwatch that records actual seconds per slide. By end of this slide you should be at ~8:45 of 10:00 (~1:15 remaining).</a:t>
-            </a:r>
-          </a:p>
         </p:txBody>
       </p:sp>
       <p:sp>
@@ -1183,12 +1141,6 @@
           <a:p>
             <a:r>
               <a:t>• Pilot fails a gate? Do not scale.</a:t>
-            </a:r>
-          </a:p>
-          <a:p/>
-          <a:p>
-            <a:r>
-              <a:t>ON-SLIDE TIMER: Budget 1:15 for this slide. Gold bar counts down in Slideshow; red MOVE ON appears when budget ends (does not auto-advance). Prefer presenter-timer.html on a second screen for a live stopwatch that records actual seconds per slide. By end of this slide you should be at ~10:00 of 10:00 (~0:00 remaining).</a:t>
             </a:r>
           </a:p>
         </p:txBody>
@@ -4285,7 +4237,7 @@
         <p:spPr>
           <a:xfrm>
             <a:off x="502920" y="438912"/>
-            <a:ext cx="8869680" cy="594360"/>
+            <a:ext cx="11155680" cy="594360"/>
           </a:xfrm>
           <a:prstGeom prst="rect">
             <a:avLst/>
@@ -4823,38 +4775,6 @@
               <a:t>4  Reuse library   →   5  Enablement cadence   →   6  Five-year profit-and-loss   →   7  Proof &amp; ask</a:t>
             </a:r>
           </a:p>
-          <a:p>
-            <a:pPr algn="l">
-              <a:spcAft>
-                <a:spcPts val="200"/>
-              </a:spcAft>
-            </a:pPr>
-            <a:r>
-              <a:rPr sz="1200" b="0">
-                <a:solidFill>
-                  <a:srgbClr val="8B9CB3"/>
-                </a:solidFill>
-                <a:latin typeface="Calibri"/>
-              </a:rPr>
-              <a:t>Top-right SLIDE BUDGET + gold bar countdown; red MOVE ON when budget ends (Slideshow).</a:t>
-            </a:r>
-          </a:p>
-          <a:p>
-            <a:pPr algn="l">
-              <a:spcAft>
-                <a:spcPts val="0"/>
-              </a:spcAft>
-            </a:pPr>
-            <a:r>
-              <a:rPr sz="1200" b="0">
-                <a:solidFill>
-                  <a:srgbClr val="8B9CB3"/>
-                </a:solidFill>
-                <a:latin typeface="Calibri"/>
-              </a:rPr>
-              <a:t>For a live stopwatch that records actual seconds/slide: open presenter-timer.html on a second screen.</a:t>
-            </a:r>
-          </a:p>
         </p:txBody>
       </p:sp>
       <p:sp>
@@ -4931,348 +4851,6 @@
                 <a:latin typeface="Calibri"/>
               </a:rPr>
               <a:t>1 / 8</a:t>
-            </a:r>
-          </a:p>
-        </p:txBody>
-      </p:sp>
-      <p:sp>
-        <p:nvSpPr>
-          <p:cNvPr id="17" name="Rounded Rectangle 16"/>
-          <p:cNvSpPr/>
-          <p:nvPr/>
-        </p:nvSpPr>
-        <p:spPr>
-          <a:xfrm>
-            <a:off x="9646920" y="164592"/>
-            <a:ext cx="2331720" cy="868680"/>
-          </a:xfrm>
-          <a:prstGeom prst="roundRect">
-            <a:avLst>
-              <a:gd name="adj" fmla="val 12000"/>
-            </a:avLst>
-          </a:prstGeom>
-          <a:solidFill>
-            <a:srgbClr val="1A2332"/>
-          </a:solidFill>
-          <a:ln>
-            <a:noFill/>
-          </a:ln>
-        </p:spPr>
-        <p:style>
-          <a:lnRef idx="1">
-            <a:schemeClr val="accent1"/>
-          </a:lnRef>
-          <a:fillRef idx="3">
-            <a:schemeClr val="accent1"/>
-          </a:fillRef>
-          <a:effectRef idx="2">
-            <a:schemeClr val="accent1"/>
-          </a:effectRef>
-          <a:fontRef idx="minor">
-            <a:schemeClr val="lt1"/>
-          </a:fontRef>
-        </p:style>
-        <p:txBody>
-          <a:bodyPr rtlCol="0" anchor="ctr"/>
-          <a:lstStyle/>
-          <a:p>
-            <a:pPr algn="ctr"/>
-          </a:p>
-        </p:txBody>
-      </p:sp>
-      <p:sp>
-        <p:nvSpPr>
-          <p:cNvPr id="18" name="Rectangle 17"/>
-          <p:cNvSpPr/>
-          <p:nvPr/>
-        </p:nvSpPr>
-        <p:spPr>
-          <a:xfrm>
-            <a:off x="9646920" y="164592"/>
-            <a:ext cx="73152" cy="868680"/>
-          </a:xfrm>
-          <a:prstGeom prst="rect">
-            <a:avLst/>
-          </a:prstGeom>
-          <a:solidFill>
-            <a:srgbClr val="D4A853"/>
-          </a:solidFill>
-          <a:ln>
-            <a:noFill/>
-          </a:ln>
-        </p:spPr>
-        <p:style>
-          <a:lnRef idx="1">
-            <a:schemeClr val="accent1"/>
-          </a:lnRef>
-          <a:fillRef idx="3">
-            <a:schemeClr val="accent1"/>
-          </a:fillRef>
-          <a:effectRef idx="2">
-            <a:schemeClr val="accent1"/>
-          </a:effectRef>
-          <a:fontRef idx="minor">
-            <a:schemeClr val="lt1"/>
-          </a:fontRef>
-        </p:style>
-        <p:txBody>
-          <a:bodyPr rtlCol="0" anchor="ctr"/>
-          <a:lstStyle/>
-          <a:p>
-            <a:pPr algn="ctr"/>
-          </a:p>
-        </p:txBody>
-      </p:sp>
-      <p:sp>
-        <p:nvSpPr>
-          <p:cNvPr id="19" name="TextBox 18"/>
-          <p:cNvSpPr txBox="1"/>
-          <p:nvPr/>
-        </p:nvSpPr>
-        <p:spPr>
-          <a:xfrm>
-            <a:off x="9811512" y="219456"/>
-            <a:ext cx="2075688" cy="777240"/>
-          </a:xfrm>
-          <a:prstGeom prst="rect">
-            <a:avLst/>
-          </a:prstGeom>
-          <a:noFill/>
-        </p:spPr>
-        <p:txBody>
-          <a:bodyPr wrap="square">
-            <a:spAutoFit/>
-          </a:bodyPr>
-          <a:lstStyle/>
-          <a:p>
-            <a:pPr algn="l">
-              <a:spcAft>
-                <a:spcPts val="0"/>
-              </a:spcAft>
-            </a:pPr>
-            <a:r>
-              <a:rPr sz="900" b="1">
-                <a:solidFill>
-                  <a:srgbClr val="8B9CB3"/>
-                </a:solidFill>
-                <a:latin typeface="Calibri"/>
-              </a:rPr>
-              <a:t>SLIDE BUDGET</a:t>
-            </a:r>
-          </a:p>
-          <a:p>
-            <a:pPr algn="l">
-              <a:spcAft>
-                <a:spcPts val="0"/>
-              </a:spcAft>
-            </a:pPr>
-            <a:r>
-              <a:rPr sz="2600" b="1">
-                <a:solidFill>
-                  <a:srgbClr val="D4A853"/>
-                </a:solidFill>
-                <a:latin typeface="Calibri"/>
-              </a:rPr>
-              <a:t>1:15</a:t>
-            </a:r>
-          </a:p>
-          <a:p>
-            <a:pPr algn="l">
-              <a:spcAft>
-                <a:spcPts val="0"/>
-              </a:spcAft>
-            </a:pPr>
-            <a:r>
-              <a:rPr sz="900" b="0">
-                <a:solidFill>
-                  <a:srgbClr val="8B9CB3"/>
-                </a:solidFill>
-                <a:latin typeface="Calibri"/>
-              </a:rPr>
-              <a:t>by end 1:15 · left 8:45</a:t>
-            </a:r>
-          </a:p>
-        </p:txBody>
-      </p:sp>
-      <p:sp>
-        <p:nvSpPr>
-          <p:cNvPr id="20" name="Rounded Rectangle 19"/>
-          <p:cNvSpPr/>
-          <p:nvPr/>
-        </p:nvSpPr>
-        <p:spPr>
-          <a:xfrm>
-            <a:off x="502920" y="5961888"/>
-            <a:ext cx="11155680" cy="109728"/>
-          </a:xfrm>
-          <a:prstGeom prst="roundRect">
-            <a:avLst>
-              <a:gd name="adj" fmla="val 50000"/>
-            </a:avLst>
-          </a:prstGeom>
-          <a:solidFill>
-            <a:srgbClr val="243044"/>
-          </a:solidFill>
-          <a:ln>
-            <a:noFill/>
-          </a:ln>
-        </p:spPr>
-        <p:style>
-          <a:lnRef idx="1">
-            <a:schemeClr val="accent1"/>
-          </a:lnRef>
-          <a:fillRef idx="3">
-            <a:schemeClr val="accent1"/>
-          </a:fillRef>
-          <a:effectRef idx="2">
-            <a:schemeClr val="accent1"/>
-          </a:effectRef>
-          <a:fontRef idx="minor">
-            <a:schemeClr val="lt1"/>
-          </a:fontRef>
-        </p:style>
-        <p:txBody>
-          <a:bodyPr rtlCol="0" anchor="ctr"/>
-          <a:lstStyle/>
-          <a:p>
-            <a:pPr algn="ctr"/>
-          </a:p>
-        </p:txBody>
-      </p:sp>
-      <p:sp>
-        <p:nvSpPr>
-          <p:cNvPr id="21" name="Rounded Rectangle 20"/>
-          <p:cNvSpPr/>
-          <p:nvPr/>
-        </p:nvSpPr>
-        <p:spPr>
-          <a:xfrm>
-            <a:off x="502920" y="5961888"/>
-            <a:ext cx="11155680" cy="109728"/>
-          </a:xfrm>
-          <a:prstGeom prst="roundRect">
-            <a:avLst>
-              <a:gd name="adj" fmla="val 50000"/>
-            </a:avLst>
-          </a:prstGeom>
-          <a:solidFill>
-            <a:srgbClr val="D4A853"/>
-          </a:solidFill>
-          <a:ln>
-            <a:noFill/>
-          </a:ln>
-        </p:spPr>
-        <p:style>
-          <a:lnRef idx="1">
-            <a:schemeClr val="accent1"/>
-          </a:lnRef>
-          <a:fillRef idx="3">
-            <a:schemeClr val="accent1"/>
-          </a:fillRef>
-          <a:effectRef idx="2">
-            <a:schemeClr val="accent1"/>
-          </a:effectRef>
-          <a:fontRef idx="minor">
-            <a:schemeClr val="lt1"/>
-          </a:fontRef>
-        </p:style>
-        <p:txBody>
-          <a:bodyPr rtlCol="0" anchor="ctr"/>
-          <a:lstStyle/>
-          <a:p>
-            <a:pPr algn="ctr"/>
-          </a:p>
-        </p:txBody>
-      </p:sp>
-      <p:sp>
-        <p:nvSpPr>
-          <p:cNvPr id="22" name="TextBox 21"/>
-          <p:cNvSpPr txBox="1"/>
-          <p:nvPr/>
-        </p:nvSpPr>
-        <p:spPr>
-          <a:xfrm>
-            <a:off x="502920" y="5760720"/>
-            <a:ext cx="5029200" cy="201168"/>
-          </a:xfrm>
-          <a:prstGeom prst="rect">
-            <a:avLst/>
-          </a:prstGeom>
-          <a:noFill/>
-        </p:spPr>
-        <p:txBody>
-          <a:bodyPr wrap="none">
-            <a:spAutoFit/>
-          </a:bodyPr>
-          <a:lstStyle/>
-          <a:p>
-            <a:pPr algn="l">
-              <a:spcAft>
-                <a:spcPts val="0"/>
-              </a:spcAft>
-            </a:pPr>
-            <a:r>
-              <a:rPr sz="800" b="0">
-                <a:solidFill>
-                  <a:srgbClr val="8B9CB3"/>
-                </a:solidFill>
-                <a:latin typeface="Calibri"/>
-              </a:rPr>
-              <a:t>Countdown starts in Slideshow · red MOVE ON appears when budget ends · does not auto-advance</a:t>
-            </a:r>
-          </a:p>
-        </p:txBody>
-      </p:sp>
-      <p:sp>
-        <p:nvSpPr>
-          <p:cNvPr id="23" name="Rounded Rectangle 22"/>
-          <p:cNvSpPr/>
-          <p:nvPr/>
-        </p:nvSpPr>
-        <p:spPr>
-          <a:xfrm>
-            <a:off x="9189720" y="5614416"/>
-            <a:ext cx="2468880" cy="292608"/>
-          </a:xfrm>
-          <a:prstGeom prst="roundRect">
-            <a:avLst>
-              <a:gd name="adj" fmla="val 20000"/>
-            </a:avLst>
-          </a:prstGeom>
-          <a:solidFill>
-            <a:srgbClr val="F87171"/>
-          </a:solidFill>
-          <a:ln>
-            <a:noFill/>
-          </a:ln>
-        </p:spPr>
-        <p:style>
-          <a:lnRef idx="1">
-            <a:schemeClr val="accent1"/>
-          </a:lnRef>
-          <a:fillRef idx="3">
-            <a:schemeClr val="accent1"/>
-          </a:fillRef>
-          <a:effectRef idx="2">
-            <a:schemeClr val="accent1"/>
-          </a:effectRef>
-          <a:fontRef idx="minor">
-            <a:schemeClr val="lt1"/>
-          </a:fontRef>
-        </p:style>
-        <p:txBody>
-          <a:bodyPr rtlCol="0" anchor="ctr" wrap="none"/>
-          <a:lstStyle/>
-          <a:p>
-            <a:pPr algn="ctr"/>
-            <a:r>
-              <a:rPr sz="1200" b="1">
-                <a:solidFill>
-                  <a:srgbClr val="E6EDF3"/>
-                </a:solidFill>
-                <a:latin typeface="Calibri"/>
-              </a:rPr>
-              <a:t>MOVE ON  →</a:t>
             </a:r>
           </a:p>
         </p:txBody>
@@ -5282,106 +4860,6 @@
   <p:clrMapOvr>
     <a:masterClrMapping/>
   </p:clrMapOvr>
-  <p:timing>
-    <p:tnLst>
-      <p:par>
-        <p:cTn id="1" dur="indefinite" restart="never" nodeType="tmRoot">
-          <p:childTnLst>
-            <p:seq concurrent="1" nextAc="seek">
-              <p:cTn id="2" dur="indefinite" nodeType="mainSeq">
-                <p:childTnLst>
-                  <p:par>
-                    <p:cTn id="3" fill="hold">
-                      <p:stCondLst>
-                        <p:cond delay="0"/>
-                      </p:stCondLst>
-                      <p:childTnLst>
-                        <p:par>
-                          <p:cTn id="4" fill="hold">
-                            <p:stCondLst>
-                              <p:cond delay="0"/>
-                            </p:stCondLst>
-                            <p:childTnLst>
-                              <p:set>
-                                <p:cBhvr>
-                                  <p:cTn id="5" dur="1" fill="hold"/>
-                                  <p:tgtEl>
-                                    <p:spTgt spid="23"/>
-                                  </p:tgtEl>
-                                  <p:attrNameLst>
-                                    <p:attrName>style.visibility</p:attrName>
-                                  </p:attrNameLst>
-                                </p:cBhvr>
-                                <p:to>
-                                  <p:strVal val="hidden"/>
-                                </p:to>
-                              </p:set>
-                              <p:animEffect transition="out" filter="wipe(left)">
-                                <p:cBhvr>
-                                  <p:cTn id="6" dur="75000" fill="hold"/>
-                                  <p:tgtEl>
-                                    <p:spTgt spid="21"/>
-                                  </p:tgtEl>
-                                </p:cBhvr>
-                              </p:animEffect>
-                              <p:animEffect transition="in" filter="fade">
-                                <p:cBhvr>
-                                  <p:cTn id="7" dur="400" fill="hold">
-                                    <p:stCondLst>
-                                      <p:cond delay="75000"/>
-                                    </p:stCondLst>
-                                  </p:cTn>
-                                  <p:tgtEl>
-                                    <p:spTgt spid="23"/>
-                                  </p:tgtEl>
-                                </p:cBhvr>
-                              </p:animEffect>
-                              <p:set>
-                                <p:cBhvr>
-                                  <p:cTn id="8" dur="1" fill="hold">
-                                    <p:stCondLst>
-                                      <p:cond delay="75000"/>
-                                    </p:stCondLst>
-                                  </p:cTn>
-                                  <p:tgtEl>
-                                    <p:spTgt spid="23"/>
-                                  </p:tgtEl>
-                                  <p:attrNameLst>
-                                    <p:attrName>style.visibility</p:attrName>
-                                  </p:attrNameLst>
-                                </p:cBhvr>
-                                <p:to>
-                                  <p:strVal val="visible"/>
-                                </p:to>
-                              </p:set>
-                            </p:childTnLst>
-                          </p:cTn>
-                        </p:par>
-                      </p:childTnLst>
-                    </p:cTn>
-                  </p:par>
-                </p:childTnLst>
-              </p:cTn>
-              <p:prevCondLst>
-                <p:cond evt="onPrev" delay="0">
-                  <p:tgtEl>
-                    <p:sldTgt/>
-                  </p:tgtEl>
-                </p:cond>
-              </p:prevCondLst>
-              <p:nextCondLst>
-                <p:cond evt="onNext" delay="0">
-                  <p:tgtEl>
-                    <p:sldTgt/>
-                  </p:tgtEl>
-                </p:cond>
-              </p:nextCondLst>
-            </p:seq>
-          </p:childTnLst>
-        </p:cTn>
-      </p:par>
-    </p:tnLst>
-  </p:timing>
 </p:sld>
 </file>
 
@@ -5486,7 +4964,7 @@
         <p:spPr>
           <a:xfrm>
             <a:off x="502920" y="438912"/>
-            <a:ext cx="8869680" cy="594360"/>
+            <a:ext cx="11155680" cy="594360"/>
           </a:xfrm>
           <a:prstGeom prst="rect">
             <a:avLst/>
@@ -7264,453 +6742,11 @@
           </a:p>
         </p:txBody>
       </p:sp>
-      <p:sp>
-        <p:nvSpPr>
-          <p:cNvPr id="41" name="Rounded Rectangle 40"/>
-          <p:cNvSpPr/>
-          <p:nvPr/>
-        </p:nvSpPr>
-        <p:spPr>
-          <a:xfrm>
-            <a:off x="9646920" y="164592"/>
-            <a:ext cx="2331720" cy="868680"/>
-          </a:xfrm>
-          <a:prstGeom prst="roundRect">
-            <a:avLst>
-              <a:gd name="adj" fmla="val 12000"/>
-            </a:avLst>
-          </a:prstGeom>
-          <a:solidFill>
-            <a:srgbClr val="1A2332"/>
-          </a:solidFill>
-          <a:ln>
-            <a:noFill/>
-          </a:ln>
-        </p:spPr>
-        <p:style>
-          <a:lnRef idx="1">
-            <a:schemeClr val="accent1"/>
-          </a:lnRef>
-          <a:fillRef idx="3">
-            <a:schemeClr val="accent1"/>
-          </a:fillRef>
-          <a:effectRef idx="2">
-            <a:schemeClr val="accent1"/>
-          </a:effectRef>
-          <a:fontRef idx="minor">
-            <a:schemeClr val="lt1"/>
-          </a:fontRef>
-        </p:style>
-        <p:txBody>
-          <a:bodyPr rtlCol="0" anchor="ctr"/>
-          <a:lstStyle/>
-          <a:p>
-            <a:pPr algn="ctr"/>
-          </a:p>
-        </p:txBody>
-      </p:sp>
-      <p:sp>
-        <p:nvSpPr>
-          <p:cNvPr id="42" name="Rectangle 41"/>
-          <p:cNvSpPr/>
-          <p:nvPr/>
-        </p:nvSpPr>
-        <p:spPr>
-          <a:xfrm>
-            <a:off x="9646920" y="164592"/>
-            <a:ext cx="73152" cy="868680"/>
-          </a:xfrm>
-          <a:prstGeom prst="rect">
-            <a:avLst/>
-          </a:prstGeom>
-          <a:solidFill>
-            <a:srgbClr val="D4A853"/>
-          </a:solidFill>
-          <a:ln>
-            <a:noFill/>
-          </a:ln>
-        </p:spPr>
-        <p:style>
-          <a:lnRef idx="1">
-            <a:schemeClr val="accent1"/>
-          </a:lnRef>
-          <a:fillRef idx="3">
-            <a:schemeClr val="accent1"/>
-          </a:fillRef>
-          <a:effectRef idx="2">
-            <a:schemeClr val="accent1"/>
-          </a:effectRef>
-          <a:fontRef idx="minor">
-            <a:schemeClr val="lt1"/>
-          </a:fontRef>
-        </p:style>
-        <p:txBody>
-          <a:bodyPr rtlCol="0" anchor="ctr"/>
-          <a:lstStyle/>
-          <a:p>
-            <a:pPr algn="ctr"/>
-          </a:p>
-        </p:txBody>
-      </p:sp>
-      <p:sp>
-        <p:nvSpPr>
-          <p:cNvPr id="43" name="TextBox 42"/>
-          <p:cNvSpPr txBox="1"/>
-          <p:nvPr/>
-        </p:nvSpPr>
-        <p:spPr>
-          <a:xfrm>
-            <a:off x="9811512" y="219456"/>
-            <a:ext cx="2075688" cy="777240"/>
-          </a:xfrm>
-          <a:prstGeom prst="rect">
-            <a:avLst/>
-          </a:prstGeom>
-          <a:noFill/>
-        </p:spPr>
-        <p:txBody>
-          <a:bodyPr wrap="square">
-            <a:spAutoFit/>
-          </a:bodyPr>
-          <a:lstStyle/>
-          <a:p>
-            <a:pPr algn="l">
-              <a:spcAft>
-                <a:spcPts val="0"/>
-              </a:spcAft>
-            </a:pPr>
-            <a:r>
-              <a:rPr sz="900" b="1">
-                <a:solidFill>
-                  <a:srgbClr val="8B9CB3"/>
-                </a:solidFill>
-                <a:latin typeface="Calibri"/>
-              </a:rPr>
-              <a:t>SLIDE BUDGET</a:t>
-            </a:r>
-          </a:p>
-          <a:p>
-            <a:pPr algn="l">
-              <a:spcAft>
-                <a:spcPts val="0"/>
-              </a:spcAft>
-            </a:pPr>
-            <a:r>
-              <a:rPr sz="2600" b="1">
-                <a:solidFill>
-                  <a:srgbClr val="D4A853"/>
-                </a:solidFill>
-                <a:latin typeface="Calibri"/>
-              </a:rPr>
-              <a:t>1:15</a:t>
-            </a:r>
-          </a:p>
-          <a:p>
-            <a:pPr algn="l">
-              <a:spcAft>
-                <a:spcPts val="0"/>
-              </a:spcAft>
-            </a:pPr>
-            <a:r>
-              <a:rPr sz="900" b="0">
-                <a:solidFill>
-                  <a:srgbClr val="8B9CB3"/>
-                </a:solidFill>
-                <a:latin typeface="Calibri"/>
-              </a:rPr>
-              <a:t>by end 2:30 · left 7:30</a:t>
-            </a:r>
-          </a:p>
-        </p:txBody>
-      </p:sp>
-      <p:sp>
-        <p:nvSpPr>
-          <p:cNvPr id="44" name="Rounded Rectangle 43"/>
-          <p:cNvSpPr/>
-          <p:nvPr/>
-        </p:nvSpPr>
-        <p:spPr>
-          <a:xfrm>
-            <a:off x="502920" y="5961888"/>
-            <a:ext cx="11155680" cy="109728"/>
-          </a:xfrm>
-          <a:prstGeom prst="roundRect">
-            <a:avLst>
-              <a:gd name="adj" fmla="val 50000"/>
-            </a:avLst>
-          </a:prstGeom>
-          <a:solidFill>
-            <a:srgbClr val="243044"/>
-          </a:solidFill>
-          <a:ln>
-            <a:noFill/>
-          </a:ln>
-        </p:spPr>
-        <p:style>
-          <a:lnRef idx="1">
-            <a:schemeClr val="accent1"/>
-          </a:lnRef>
-          <a:fillRef idx="3">
-            <a:schemeClr val="accent1"/>
-          </a:fillRef>
-          <a:effectRef idx="2">
-            <a:schemeClr val="accent1"/>
-          </a:effectRef>
-          <a:fontRef idx="minor">
-            <a:schemeClr val="lt1"/>
-          </a:fontRef>
-        </p:style>
-        <p:txBody>
-          <a:bodyPr rtlCol="0" anchor="ctr"/>
-          <a:lstStyle/>
-          <a:p>
-            <a:pPr algn="ctr"/>
-          </a:p>
-        </p:txBody>
-      </p:sp>
-      <p:sp>
-        <p:nvSpPr>
-          <p:cNvPr id="45" name="Rounded Rectangle 44"/>
-          <p:cNvSpPr/>
-          <p:nvPr/>
-        </p:nvSpPr>
-        <p:spPr>
-          <a:xfrm>
-            <a:off x="502920" y="5961888"/>
-            <a:ext cx="11155680" cy="109728"/>
-          </a:xfrm>
-          <a:prstGeom prst="roundRect">
-            <a:avLst>
-              <a:gd name="adj" fmla="val 50000"/>
-            </a:avLst>
-          </a:prstGeom>
-          <a:solidFill>
-            <a:srgbClr val="D4A853"/>
-          </a:solidFill>
-          <a:ln>
-            <a:noFill/>
-          </a:ln>
-        </p:spPr>
-        <p:style>
-          <a:lnRef idx="1">
-            <a:schemeClr val="accent1"/>
-          </a:lnRef>
-          <a:fillRef idx="3">
-            <a:schemeClr val="accent1"/>
-          </a:fillRef>
-          <a:effectRef idx="2">
-            <a:schemeClr val="accent1"/>
-          </a:effectRef>
-          <a:fontRef idx="minor">
-            <a:schemeClr val="lt1"/>
-          </a:fontRef>
-        </p:style>
-        <p:txBody>
-          <a:bodyPr rtlCol="0" anchor="ctr"/>
-          <a:lstStyle/>
-          <a:p>
-            <a:pPr algn="ctr"/>
-          </a:p>
-        </p:txBody>
-      </p:sp>
-      <p:sp>
-        <p:nvSpPr>
-          <p:cNvPr id="46" name="TextBox 45"/>
-          <p:cNvSpPr txBox="1"/>
-          <p:nvPr/>
-        </p:nvSpPr>
-        <p:spPr>
-          <a:xfrm>
-            <a:off x="502920" y="5760720"/>
-            <a:ext cx="5029200" cy="201168"/>
-          </a:xfrm>
-          <a:prstGeom prst="rect">
-            <a:avLst/>
-          </a:prstGeom>
-          <a:noFill/>
-        </p:spPr>
-        <p:txBody>
-          <a:bodyPr wrap="none">
-            <a:spAutoFit/>
-          </a:bodyPr>
-          <a:lstStyle/>
-          <a:p>
-            <a:pPr algn="l">
-              <a:spcAft>
-                <a:spcPts val="0"/>
-              </a:spcAft>
-            </a:pPr>
-            <a:r>
-              <a:rPr sz="800" b="0">
-                <a:solidFill>
-                  <a:srgbClr val="8B9CB3"/>
-                </a:solidFill>
-                <a:latin typeface="Calibri"/>
-              </a:rPr>
-              <a:t>Countdown starts in Slideshow · red MOVE ON appears when budget ends · does not auto-advance</a:t>
-            </a:r>
-          </a:p>
-        </p:txBody>
-      </p:sp>
-      <p:sp>
-        <p:nvSpPr>
-          <p:cNvPr id="47" name="Rounded Rectangle 46"/>
-          <p:cNvSpPr/>
-          <p:nvPr/>
-        </p:nvSpPr>
-        <p:spPr>
-          <a:xfrm>
-            <a:off x="9189720" y="5614416"/>
-            <a:ext cx="2468880" cy="292608"/>
-          </a:xfrm>
-          <a:prstGeom prst="roundRect">
-            <a:avLst>
-              <a:gd name="adj" fmla="val 20000"/>
-            </a:avLst>
-          </a:prstGeom>
-          <a:solidFill>
-            <a:srgbClr val="F87171"/>
-          </a:solidFill>
-          <a:ln>
-            <a:noFill/>
-          </a:ln>
-        </p:spPr>
-        <p:style>
-          <a:lnRef idx="1">
-            <a:schemeClr val="accent1"/>
-          </a:lnRef>
-          <a:fillRef idx="3">
-            <a:schemeClr val="accent1"/>
-          </a:fillRef>
-          <a:effectRef idx="2">
-            <a:schemeClr val="accent1"/>
-          </a:effectRef>
-          <a:fontRef idx="minor">
-            <a:schemeClr val="lt1"/>
-          </a:fontRef>
-        </p:style>
-        <p:txBody>
-          <a:bodyPr rtlCol="0" anchor="ctr" wrap="none"/>
-          <a:lstStyle/>
-          <a:p>
-            <a:pPr algn="ctr"/>
-            <a:r>
-              <a:rPr sz="1200" b="1">
-                <a:solidFill>
-                  <a:srgbClr val="E6EDF3"/>
-                </a:solidFill>
-                <a:latin typeface="Calibri"/>
-              </a:rPr>
-              <a:t>MOVE ON  →</a:t>
-            </a:r>
-          </a:p>
-        </p:txBody>
-      </p:sp>
     </p:spTree>
   </p:cSld>
   <p:clrMapOvr>
     <a:masterClrMapping/>
   </p:clrMapOvr>
-  <p:timing>
-    <p:tnLst>
-      <p:par>
-        <p:cTn id="1" dur="indefinite" restart="never" nodeType="tmRoot">
-          <p:childTnLst>
-            <p:seq concurrent="1" nextAc="seek">
-              <p:cTn id="2" dur="indefinite" nodeType="mainSeq">
-                <p:childTnLst>
-                  <p:par>
-                    <p:cTn id="3" fill="hold">
-                      <p:stCondLst>
-                        <p:cond delay="0"/>
-                      </p:stCondLst>
-                      <p:childTnLst>
-                        <p:par>
-                          <p:cTn id="4" fill="hold">
-                            <p:stCondLst>
-                              <p:cond delay="0"/>
-                            </p:stCondLst>
-                            <p:childTnLst>
-                              <p:set>
-                                <p:cBhvr>
-                                  <p:cTn id="5" dur="1" fill="hold"/>
-                                  <p:tgtEl>
-                                    <p:spTgt spid="47"/>
-                                  </p:tgtEl>
-                                  <p:attrNameLst>
-                                    <p:attrName>style.visibility</p:attrName>
-                                  </p:attrNameLst>
-                                </p:cBhvr>
-                                <p:to>
-                                  <p:strVal val="hidden"/>
-                                </p:to>
-                              </p:set>
-                              <p:animEffect transition="out" filter="wipe(left)">
-                                <p:cBhvr>
-                                  <p:cTn id="6" dur="75000" fill="hold"/>
-                                  <p:tgtEl>
-                                    <p:spTgt spid="45"/>
-                                  </p:tgtEl>
-                                </p:cBhvr>
-                              </p:animEffect>
-                              <p:animEffect transition="in" filter="fade">
-                                <p:cBhvr>
-                                  <p:cTn id="7" dur="400" fill="hold">
-                                    <p:stCondLst>
-                                      <p:cond delay="75000"/>
-                                    </p:stCondLst>
-                                  </p:cTn>
-                                  <p:tgtEl>
-                                    <p:spTgt spid="47"/>
-                                  </p:tgtEl>
-                                </p:cBhvr>
-                              </p:animEffect>
-                              <p:set>
-                                <p:cBhvr>
-                                  <p:cTn id="8" dur="1" fill="hold">
-                                    <p:stCondLst>
-                                      <p:cond delay="75000"/>
-                                    </p:stCondLst>
-                                  </p:cTn>
-                                  <p:tgtEl>
-                                    <p:spTgt spid="47"/>
-                                  </p:tgtEl>
-                                  <p:attrNameLst>
-                                    <p:attrName>style.visibility</p:attrName>
-                                  </p:attrNameLst>
-                                </p:cBhvr>
-                                <p:to>
-                                  <p:strVal val="visible"/>
-                                </p:to>
-                              </p:set>
-                            </p:childTnLst>
-                          </p:cTn>
-                        </p:par>
-                      </p:childTnLst>
-                    </p:cTn>
-                  </p:par>
-                </p:childTnLst>
-              </p:cTn>
-              <p:prevCondLst>
-                <p:cond evt="onPrev" delay="0">
-                  <p:tgtEl>
-                    <p:sldTgt/>
-                  </p:tgtEl>
-                </p:cond>
-              </p:prevCondLst>
-              <p:nextCondLst>
-                <p:cond evt="onNext" delay="0">
-                  <p:tgtEl>
-                    <p:sldTgt/>
-                  </p:tgtEl>
-                </p:cond>
-              </p:nextCondLst>
-            </p:seq>
-          </p:childTnLst>
-        </p:cTn>
-      </p:par>
-    </p:tnLst>
-  </p:timing>
 </p:sld>
 </file>
 
@@ -7815,7 +6851,7 @@
         <p:spPr>
           <a:xfrm>
             <a:off x="502920" y="438912"/>
-            <a:ext cx="8869680" cy="594360"/>
+            <a:ext cx="11155680" cy="594360"/>
           </a:xfrm>
           <a:prstGeom prst="rect">
             <a:avLst/>
@@ -9284,453 +8320,11 @@
           </a:p>
         </p:txBody>
       </p:sp>
-      <p:sp>
-        <p:nvSpPr>
-          <p:cNvPr id="36" name="Rounded Rectangle 35"/>
-          <p:cNvSpPr/>
-          <p:nvPr/>
-        </p:nvSpPr>
-        <p:spPr>
-          <a:xfrm>
-            <a:off x="9646920" y="164592"/>
-            <a:ext cx="2331720" cy="868680"/>
-          </a:xfrm>
-          <a:prstGeom prst="roundRect">
-            <a:avLst>
-              <a:gd name="adj" fmla="val 12000"/>
-            </a:avLst>
-          </a:prstGeom>
-          <a:solidFill>
-            <a:srgbClr val="1A2332"/>
-          </a:solidFill>
-          <a:ln>
-            <a:noFill/>
-          </a:ln>
-        </p:spPr>
-        <p:style>
-          <a:lnRef idx="1">
-            <a:schemeClr val="accent1"/>
-          </a:lnRef>
-          <a:fillRef idx="3">
-            <a:schemeClr val="accent1"/>
-          </a:fillRef>
-          <a:effectRef idx="2">
-            <a:schemeClr val="accent1"/>
-          </a:effectRef>
-          <a:fontRef idx="minor">
-            <a:schemeClr val="lt1"/>
-          </a:fontRef>
-        </p:style>
-        <p:txBody>
-          <a:bodyPr rtlCol="0" anchor="ctr"/>
-          <a:lstStyle/>
-          <a:p>
-            <a:pPr algn="ctr"/>
-          </a:p>
-        </p:txBody>
-      </p:sp>
-      <p:sp>
-        <p:nvSpPr>
-          <p:cNvPr id="37" name="Rectangle 36"/>
-          <p:cNvSpPr/>
-          <p:nvPr/>
-        </p:nvSpPr>
-        <p:spPr>
-          <a:xfrm>
-            <a:off x="9646920" y="164592"/>
-            <a:ext cx="73152" cy="868680"/>
-          </a:xfrm>
-          <a:prstGeom prst="rect">
-            <a:avLst/>
-          </a:prstGeom>
-          <a:solidFill>
-            <a:srgbClr val="D4A853"/>
-          </a:solidFill>
-          <a:ln>
-            <a:noFill/>
-          </a:ln>
-        </p:spPr>
-        <p:style>
-          <a:lnRef idx="1">
-            <a:schemeClr val="accent1"/>
-          </a:lnRef>
-          <a:fillRef idx="3">
-            <a:schemeClr val="accent1"/>
-          </a:fillRef>
-          <a:effectRef idx="2">
-            <a:schemeClr val="accent1"/>
-          </a:effectRef>
-          <a:fontRef idx="minor">
-            <a:schemeClr val="lt1"/>
-          </a:fontRef>
-        </p:style>
-        <p:txBody>
-          <a:bodyPr rtlCol="0" anchor="ctr"/>
-          <a:lstStyle/>
-          <a:p>
-            <a:pPr algn="ctr"/>
-          </a:p>
-        </p:txBody>
-      </p:sp>
-      <p:sp>
-        <p:nvSpPr>
-          <p:cNvPr id="38" name="TextBox 37"/>
-          <p:cNvSpPr txBox="1"/>
-          <p:nvPr/>
-        </p:nvSpPr>
-        <p:spPr>
-          <a:xfrm>
-            <a:off x="9811512" y="219456"/>
-            <a:ext cx="2075688" cy="777240"/>
-          </a:xfrm>
-          <a:prstGeom prst="rect">
-            <a:avLst/>
-          </a:prstGeom>
-          <a:noFill/>
-        </p:spPr>
-        <p:txBody>
-          <a:bodyPr wrap="square">
-            <a:spAutoFit/>
-          </a:bodyPr>
-          <a:lstStyle/>
-          <a:p>
-            <a:pPr algn="l">
-              <a:spcAft>
-                <a:spcPts val="0"/>
-              </a:spcAft>
-            </a:pPr>
-            <a:r>
-              <a:rPr sz="900" b="1">
-                <a:solidFill>
-                  <a:srgbClr val="8B9CB3"/>
-                </a:solidFill>
-                <a:latin typeface="Calibri"/>
-              </a:rPr>
-              <a:t>SLIDE BUDGET</a:t>
-            </a:r>
-          </a:p>
-          <a:p>
-            <a:pPr algn="l">
-              <a:spcAft>
-                <a:spcPts val="0"/>
-              </a:spcAft>
-            </a:pPr>
-            <a:r>
-              <a:rPr sz="2600" b="1">
-                <a:solidFill>
-                  <a:srgbClr val="D4A853"/>
-                </a:solidFill>
-                <a:latin typeface="Calibri"/>
-              </a:rPr>
-              <a:t>1:15</a:t>
-            </a:r>
-          </a:p>
-          <a:p>
-            <a:pPr algn="l">
-              <a:spcAft>
-                <a:spcPts val="0"/>
-              </a:spcAft>
-            </a:pPr>
-            <a:r>
-              <a:rPr sz="900" b="0">
-                <a:solidFill>
-                  <a:srgbClr val="8B9CB3"/>
-                </a:solidFill>
-                <a:latin typeface="Calibri"/>
-              </a:rPr>
-              <a:t>by end 3:45 · left 6:15</a:t>
-            </a:r>
-          </a:p>
-        </p:txBody>
-      </p:sp>
-      <p:sp>
-        <p:nvSpPr>
-          <p:cNvPr id="39" name="Rounded Rectangle 38"/>
-          <p:cNvSpPr/>
-          <p:nvPr/>
-        </p:nvSpPr>
-        <p:spPr>
-          <a:xfrm>
-            <a:off x="502920" y="5961888"/>
-            <a:ext cx="11155680" cy="109728"/>
-          </a:xfrm>
-          <a:prstGeom prst="roundRect">
-            <a:avLst>
-              <a:gd name="adj" fmla="val 50000"/>
-            </a:avLst>
-          </a:prstGeom>
-          <a:solidFill>
-            <a:srgbClr val="243044"/>
-          </a:solidFill>
-          <a:ln>
-            <a:noFill/>
-          </a:ln>
-        </p:spPr>
-        <p:style>
-          <a:lnRef idx="1">
-            <a:schemeClr val="accent1"/>
-          </a:lnRef>
-          <a:fillRef idx="3">
-            <a:schemeClr val="accent1"/>
-          </a:fillRef>
-          <a:effectRef idx="2">
-            <a:schemeClr val="accent1"/>
-          </a:effectRef>
-          <a:fontRef idx="minor">
-            <a:schemeClr val="lt1"/>
-          </a:fontRef>
-        </p:style>
-        <p:txBody>
-          <a:bodyPr rtlCol="0" anchor="ctr"/>
-          <a:lstStyle/>
-          <a:p>
-            <a:pPr algn="ctr"/>
-          </a:p>
-        </p:txBody>
-      </p:sp>
-      <p:sp>
-        <p:nvSpPr>
-          <p:cNvPr id="40" name="Rounded Rectangle 39"/>
-          <p:cNvSpPr/>
-          <p:nvPr/>
-        </p:nvSpPr>
-        <p:spPr>
-          <a:xfrm>
-            <a:off x="502920" y="5961888"/>
-            <a:ext cx="11155680" cy="109728"/>
-          </a:xfrm>
-          <a:prstGeom prst="roundRect">
-            <a:avLst>
-              <a:gd name="adj" fmla="val 50000"/>
-            </a:avLst>
-          </a:prstGeom>
-          <a:solidFill>
-            <a:srgbClr val="D4A853"/>
-          </a:solidFill>
-          <a:ln>
-            <a:noFill/>
-          </a:ln>
-        </p:spPr>
-        <p:style>
-          <a:lnRef idx="1">
-            <a:schemeClr val="accent1"/>
-          </a:lnRef>
-          <a:fillRef idx="3">
-            <a:schemeClr val="accent1"/>
-          </a:fillRef>
-          <a:effectRef idx="2">
-            <a:schemeClr val="accent1"/>
-          </a:effectRef>
-          <a:fontRef idx="minor">
-            <a:schemeClr val="lt1"/>
-          </a:fontRef>
-        </p:style>
-        <p:txBody>
-          <a:bodyPr rtlCol="0" anchor="ctr"/>
-          <a:lstStyle/>
-          <a:p>
-            <a:pPr algn="ctr"/>
-          </a:p>
-        </p:txBody>
-      </p:sp>
-      <p:sp>
-        <p:nvSpPr>
-          <p:cNvPr id="41" name="TextBox 40"/>
-          <p:cNvSpPr txBox="1"/>
-          <p:nvPr/>
-        </p:nvSpPr>
-        <p:spPr>
-          <a:xfrm>
-            <a:off x="502920" y="5760720"/>
-            <a:ext cx="5029200" cy="201168"/>
-          </a:xfrm>
-          <a:prstGeom prst="rect">
-            <a:avLst/>
-          </a:prstGeom>
-          <a:noFill/>
-        </p:spPr>
-        <p:txBody>
-          <a:bodyPr wrap="none">
-            <a:spAutoFit/>
-          </a:bodyPr>
-          <a:lstStyle/>
-          <a:p>
-            <a:pPr algn="l">
-              <a:spcAft>
-                <a:spcPts val="0"/>
-              </a:spcAft>
-            </a:pPr>
-            <a:r>
-              <a:rPr sz="800" b="0">
-                <a:solidFill>
-                  <a:srgbClr val="8B9CB3"/>
-                </a:solidFill>
-                <a:latin typeface="Calibri"/>
-              </a:rPr>
-              <a:t>Countdown starts in Slideshow · red MOVE ON appears when budget ends · does not auto-advance</a:t>
-            </a:r>
-          </a:p>
-        </p:txBody>
-      </p:sp>
-      <p:sp>
-        <p:nvSpPr>
-          <p:cNvPr id="42" name="Rounded Rectangle 41"/>
-          <p:cNvSpPr/>
-          <p:nvPr/>
-        </p:nvSpPr>
-        <p:spPr>
-          <a:xfrm>
-            <a:off x="9189720" y="5614416"/>
-            <a:ext cx="2468880" cy="292608"/>
-          </a:xfrm>
-          <a:prstGeom prst="roundRect">
-            <a:avLst>
-              <a:gd name="adj" fmla="val 20000"/>
-            </a:avLst>
-          </a:prstGeom>
-          <a:solidFill>
-            <a:srgbClr val="F87171"/>
-          </a:solidFill>
-          <a:ln>
-            <a:noFill/>
-          </a:ln>
-        </p:spPr>
-        <p:style>
-          <a:lnRef idx="1">
-            <a:schemeClr val="accent1"/>
-          </a:lnRef>
-          <a:fillRef idx="3">
-            <a:schemeClr val="accent1"/>
-          </a:fillRef>
-          <a:effectRef idx="2">
-            <a:schemeClr val="accent1"/>
-          </a:effectRef>
-          <a:fontRef idx="minor">
-            <a:schemeClr val="lt1"/>
-          </a:fontRef>
-        </p:style>
-        <p:txBody>
-          <a:bodyPr rtlCol="0" anchor="ctr" wrap="none"/>
-          <a:lstStyle/>
-          <a:p>
-            <a:pPr algn="ctr"/>
-            <a:r>
-              <a:rPr sz="1200" b="1">
-                <a:solidFill>
-                  <a:srgbClr val="E6EDF3"/>
-                </a:solidFill>
-                <a:latin typeface="Calibri"/>
-              </a:rPr>
-              <a:t>MOVE ON  →</a:t>
-            </a:r>
-          </a:p>
-        </p:txBody>
-      </p:sp>
     </p:spTree>
   </p:cSld>
   <p:clrMapOvr>
     <a:masterClrMapping/>
   </p:clrMapOvr>
-  <p:timing>
-    <p:tnLst>
-      <p:par>
-        <p:cTn id="1" dur="indefinite" restart="never" nodeType="tmRoot">
-          <p:childTnLst>
-            <p:seq concurrent="1" nextAc="seek">
-              <p:cTn id="2" dur="indefinite" nodeType="mainSeq">
-                <p:childTnLst>
-                  <p:par>
-                    <p:cTn id="3" fill="hold">
-                      <p:stCondLst>
-                        <p:cond delay="0"/>
-                      </p:stCondLst>
-                      <p:childTnLst>
-                        <p:par>
-                          <p:cTn id="4" fill="hold">
-                            <p:stCondLst>
-                              <p:cond delay="0"/>
-                            </p:stCondLst>
-                            <p:childTnLst>
-                              <p:set>
-                                <p:cBhvr>
-                                  <p:cTn id="5" dur="1" fill="hold"/>
-                                  <p:tgtEl>
-                                    <p:spTgt spid="42"/>
-                                  </p:tgtEl>
-                                  <p:attrNameLst>
-                                    <p:attrName>style.visibility</p:attrName>
-                                  </p:attrNameLst>
-                                </p:cBhvr>
-                                <p:to>
-                                  <p:strVal val="hidden"/>
-                                </p:to>
-                              </p:set>
-                              <p:animEffect transition="out" filter="wipe(left)">
-                                <p:cBhvr>
-                                  <p:cTn id="6" dur="75000" fill="hold"/>
-                                  <p:tgtEl>
-                                    <p:spTgt spid="40"/>
-                                  </p:tgtEl>
-                                </p:cBhvr>
-                              </p:animEffect>
-                              <p:animEffect transition="in" filter="fade">
-                                <p:cBhvr>
-                                  <p:cTn id="7" dur="400" fill="hold">
-                                    <p:stCondLst>
-                                      <p:cond delay="75000"/>
-                                    </p:stCondLst>
-                                  </p:cTn>
-                                  <p:tgtEl>
-                                    <p:spTgt spid="42"/>
-                                  </p:tgtEl>
-                                </p:cBhvr>
-                              </p:animEffect>
-                              <p:set>
-                                <p:cBhvr>
-                                  <p:cTn id="8" dur="1" fill="hold">
-                                    <p:stCondLst>
-                                      <p:cond delay="75000"/>
-                                    </p:stCondLst>
-                                  </p:cTn>
-                                  <p:tgtEl>
-                                    <p:spTgt spid="42"/>
-                                  </p:tgtEl>
-                                  <p:attrNameLst>
-                                    <p:attrName>style.visibility</p:attrName>
-                                  </p:attrNameLst>
-                                </p:cBhvr>
-                                <p:to>
-                                  <p:strVal val="visible"/>
-                                </p:to>
-                              </p:set>
-                            </p:childTnLst>
-                          </p:cTn>
-                        </p:par>
-                      </p:childTnLst>
-                    </p:cTn>
-                  </p:par>
-                </p:childTnLst>
-              </p:cTn>
-              <p:prevCondLst>
-                <p:cond evt="onPrev" delay="0">
-                  <p:tgtEl>
-                    <p:sldTgt/>
-                  </p:tgtEl>
-                </p:cond>
-              </p:prevCondLst>
-              <p:nextCondLst>
-                <p:cond evt="onNext" delay="0">
-                  <p:tgtEl>
-                    <p:sldTgt/>
-                  </p:tgtEl>
-                </p:cond>
-              </p:nextCondLst>
-            </p:seq>
-          </p:childTnLst>
-        </p:cTn>
-      </p:par>
-    </p:tnLst>
-  </p:timing>
 </p:sld>
 </file>
 
@@ -9835,7 +8429,7 @@
         <p:spPr>
           <a:xfrm>
             <a:off x="502920" y="438912"/>
-            <a:ext cx="8869680" cy="594360"/>
+            <a:ext cx="11155680" cy="594360"/>
           </a:xfrm>
           <a:prstGeom prst="rect">
             <a:avLst/>
@@ -11100,453 +9694,11 @@
           </a:p>
         </p:txBody>
       </p:sp>
-      <p:sp>
-        <p:nvSpPr>
-          <p:cNvPr id="30" name="Rounded Rectangle 29"/>
-          <p:cNvSpPr/>
-          <p:nvPr/>
-        </p:nvSpPr>
-        <p:spPr>
-          <a:xfrm>
-            <a:off x="9646920" y="164592"/>
-            <a:ext cx="2331720" cy="868680"/>
-          </a:xfrm>
-          <a:prstGeom prst="roundRect">
-            <a:avLst>
-              <a:gd name="adj" fmla="val 12000"/>
-            </a:avLst>
-          </a:prstGeom>
-          <a:solidFill>
-            <a:srgbClr val="1A2332"/>
-          </a:solidFill>
-          <a:ln>
-            <a:noFill/>
-          </a:ln>
-        </p:spPr>
-        <p:style>
-          <a:lnRef idx="1">
-            <a:schemeClr val="accent1"/>
-          </a:lnRef>
-          <a:fillRef idx="3">
-            <a:schemeClr val="accent1"/>
-          </a:fillRef>
-          <a:effectRef idx="2">
-            <a:schemeClr val="accent1"/>
-          </a:effectRef>
-          <a:fontRef idx="minor">
-            <a:schemeClr val="lt1"/>
-          </a:fontRef>
-        </p:style>
-        <p:txBody>
-          <a:bodyPr rtlCol="0" anchor="ctr"/>
-          <a:lstStyle/>
-          <a:p>
-            <a:pPr algn="ctr"/>
-          </a:p>
-        </p:txBody>
-      </p:sp>
-      <p:sp>
-        <p:nvSpPr>
-          <p:cNvPr id="31" name="Rectangle 30"/>
-          <p:cNvSpPr/>
-          <p:nvPr/>
-        </p:nvSpPr>
-        <p:spPr>
-          <a:xfrm>
-            <a:off x="9646920" y="164592"/>
-            <a:ext cx="73152" cy="868680"/>
-          </a:xfrm>
-          <a:prstGeom prst="rect">
-            <a:avLst/>
-          </a:prstGeom>
-          <a:solidFill>
-            <a:srgbClr val="D4A853"/>
-          </a:solidFill>
-          <a:ln>
-            <a:noFill/>
-          </a:ln>
-        </p:spPr>
-        <p:style>
-          <a:lnRef idx="1">
-            <a:schemeClr val="accent1"/>
-          </a:lnRef>
-          <a:fillRef idx="3">
-            <a:schemeClr val="accent1"/>
-          </a:fillRef>
-          <a:effectRef idx="2">
-            <a:schemeClr val="accent1"/>
-          </a:effectRef>
-          <a:fontRef idx="minor">
-            <a:schemeClr val="lt1"/>
-          </a:fontRef>
-        </p:style>
-        <p:txBody>
-          <a:bodyPr rtlCol="0" anchor="ctr"/>
-          <a:lstStyle/>
-          <a:p>
-            <a:pPr algn="ctr"/>
-          </a:p>
-        </p:txBody>
-      </p:sp>
-      <p:sp>
-        <p:nvSpPr>
-          <p:cNvPr id="32" name="TextBox 31"/>
-          <p:cNvSpPr txBox="1"/>
-          <p:nvPr/>
-        </p:nvSpPr>
-        <p:spPr>
-          <a:xfrm>
-            <a:off x="9811512" y="219456"/>
-            <a:ext cx="2075688" cy="777240"/>
-          </a:xfrm>
-          <a:prstGeom prst="rect">
-            <a:avLst/>
-          </a:prstGeom>
-          <a:noFill/>
-        </p:spPr>
-        <p:txBody>
-          <a:bodyPr wrap="square">
-            <a:spAutoFit/>
-          </a:bodyPr>
-          <a:lstStyle/>
-          <a:p>
-            <a:pPr algn="l">
-              <a:spcAft>
-                <a:spcPts val="0"/>
-              </a:spcAft>
-            </a:pPr>
-            <a:r>
-              <a:rPr sz="900" b="1">
-                <a:solidFill>
-                  <a:srgbClr val="8B9CB3"/>
-                </a:solidFill>
-                <a:latin typeface="Calibri"/>
-              </a:rPr>
-              <a:t>SLIDE BUDGET</a:t>
-            </a:r>
-          </a:p>
-          <a:p>
-            <a:pPr algn="l">
-              <a:spcAft>
-                <a:spcPts val="0"/>
-              </a:spcAft>
-            </a:pPr>
-            <a:r>
-              <a:rPr sz="2600" b="1">
-                <a:solidFill>
-                  <a:srgbClr val="D4A853"/>
-                </a:solidFill>
-                <a:latin typeface="Calibri"/>
-              </a:rPr>
-              <a:t>1:15</a:t>
-            </a:r>
-          </a:p>
-          <a:p>
-            <a:pPr algn="l">
-              <a:spcAft>
-                <a:spcPts val="0"/>
-              </a:spcAft>
-            </a:pPr>
-            <a:r>
-              <a:rPr sz="900" b="0">
-                <a:solidFill>
-                  <a:srgbClr val="8B9CB3"/>
-                </a:solidFill>
-                <a:latin typeface="Calibri"/>
-              </a:rPr>
-              <a:t>by end 5:00 · left 5:00</a:t>
-            </a:r>
-          </a:p>
-        </p:txBody>
-      </p:sp>
-      <p:sp>
-        <p:nvSpPr>
-          <p:cNvPr id="33" name="Rounded Rectangle 32"/>
-          <p:cNvSpPr/>
-          <p:nvPr/>
-        </p:nvSpPr>
-        <p:spPr>
-          <a:xfrm>
-            <a:off x="502920" y="5961888"/>
-            <a:ext cx="11155680" cy="109728"/>
-          </a:xfrm>
-          <a:prstGeom prst="roundRect">
-            <a:avLst>
-              <a:gd name="adj" fmla="val 50000"/>
-            </a:avLst>
-          </a:prstGeom>
-          <a:solidFill>
-            <a:srgbClr val="243044"/>
-          </a:solidFill>
-          <a:ln>
-            <a:noFill/>
-          </a:ln>
-        </p:spPr>
-        <p:style>
-          <a:lnRef idx="1">
-            <a:schemeClr val="accent1"/>
-          </a:lnRef>
-          <a:fillRef idx="3">
-            <a:schemeClr val="accent1"/>
-          </a:fillRef>
-          <a:effectRef idx="2">
-            <a:schemeClr val="accent1"/>
-          </a:effectRef>
-          <a:fontRef idx="minor">
-            <a:schemeClr val="lt1"/>
-          </a:fontRef>
-        </p:style>
-        <p:txBody>
-          <a:bodyPr rtlCol="0" anchor="ctr"/>
-          <a:lstStyle/>
-          <a:p>
-            <a:pPr algn="ctr"/>
-          </a:p>
-        </p:txBody>
-      </p:sp>
-      <p:sp>
-        <p:nvSpPr>
-          <p:cNvPr id="34" name="Rounded Rectangle 33"/>
-          <p:cNvSpPr/>
-          <p:nvPr/>
-        </p:nvSpPr>
-        <p:spPr>
-          <a:xfrm>
-            <a:off x="502920" y="5961888"/>
-            <a:ext cx="11155680" cy="109728"/>
-          </a:xfrm>
-          <a:prstGeom prst="roundRect">
-            <a:avLst>
-              <a:gd name="adj" fmla="val 50000"/>
-            </a:avLst>
-          </a:prstGeom>
-          <a:solidFill>
-            <a:srgbClr val="D4A853"/>
-          </a:solidFill>
-          <a:ln>
-            <a:noFill/>
-          </a:ln>
-        </p:spPr>
-        <p:style>
-          <a:lnRef idx="1">
-            <a:schemeClr val="accent1"/>
-          </a:lnRef>
-          <a:fillRef idx="3">
-            <a:schemeClr val="accent1"/>
-          </a:fillRef>
-          <a:effectRef idx="2">
-            <a:schemeClr val="accent1"/>
-          </a:effectRef>
-          <a:fontRef idx="minor">
-            <a:schemeClr val="lt1"/>
-          </a:fontRef>
-        </p:style>
-        <p:txBody>
-          <a:bodyPr rtlCol="0" anchor="ctr"/>
-          <a:lstStyle/>
-          <a:p>
-            <a:pPr algn="ctr"/>
-          </a:p>
-        </p:txBody>
-      </p:sp>
-      <p:sp>
-        <p:nvSpPr>
-          <p:cNvPr id="35" name="TextBox 34"/>
-          <p:cNvSpPr txBox="1"/>
-          <p:nvPr/>
-        </p:nvSpPr>
-        <p:spPr>
-          <a:xfrm>
-            <a:off x="502920" y="5760720"/>
-            <a:ext cx="5029200" cy="201168"/>
-          </a:xfrm>
-          <a:prstGeom prst="rect">
-            <a:avLst/>
-          </a:prstGeom>
-          <a:noFill/>
-        </p:spPr>
-        <p:txBody>
-          <a:bodyPr wrap="none">
-            <a:spAutoFit/>
-          </a:bodyPr>
-          <a:lstStyle/>
-          <a:p>
-            <a:pPr algn="l">
-              <a:spcAft>
-                <a:spcPts val="0"/>
-              </a:spcAft>
-            </a:pPr>
-            <a:r>
-              <a:rPr sz="800" b="0">
-                <a:solidFill>
-                  <a:srgbClr val="8B9CB3"/>
-                </a:solidFill>
-                <a:latin typeface="Calibri"/>
-              </a:rPr>
-              <a:t>Countdown starts in Slideshow · red MOVE ON appears when budget ends · does not auto-advance</a:t>
-            </a:r>
-          </a:p>
-        </p:txBody>
-      </p:sp>
-      <p:sp>
-        <p:nvSpPr>
-          <p:cNvPr id="36" name="Rounded Rectangle 35"/>
-          <p:cNvSpPr/>
-          <p:nvPr/>
-        </p:nvSpPr>
-        <p:spPr>
-          <a:xfrm>
-            <a:off x="9189720" y="5614416"/>
-            <a:ext cx="2468880" cy="292608"/>
-          </a:xfrm>
-          <a:prstGeom prst="roundRect">
-            <a:avLst>
-              <a:gd name="adj" fmla="val 20000"/>
-            </a:avLst>
-          </a:prstGeom>
-          <a:solidFill>
-            <a:srgbClr val="F87171"/>
-          </a:solidFill>
-          <a:ln>
-            <a:noFill/>
-          </a:ln>
-        </p:spPr>
-        <p:style>
-          <a:lnRef idx="1">
-            <a:schemeClr val="accent1"/>
-          </a:lnRef>
-          <a:fillRef idx="3">
-            <a:schemeClr val="accent1"/>
-          </a:fillRef>
-          <a:effectRef idx="2">
-            <a:schemeClr val="accent1"/>
-          </a:effectRef>
-          <a:fontRef idx="minor">
-            <a:schemeClr val="lt1"/>
-          </a:fontRef>
-        </p:style>
-        <p:txBody>
-          <a:bodyPr rtlCol="0" anchor="ctr" wrap="none"/>
-          <a:lstStyle/>
-          <a:p>
-            <a:pPr algn="ctr"/>
-            <a:r>
-              <a:rPr sz="1200" b="1">
-                <a:solidFill>
-                  <a:srgbClr val="E6EDF3"/>
-                </a:solidFill>
-                <a:latin typeface="Calibri"/>
-              </a:rPr>
-              <a:t>MOVE ON  →</a:t>
-            </a:r>
-          </a:p>
-        </p:txBody>
-      </p:sp>
     </p:spTree>
   </p:cSld>
   <p:clrMapOvr>
     <a:masterClrMapping/>
   </p:clrMapOvr>
-  <p:timing>
-    <p:tnLst>
-      <p:par>
-        <p:cTn id="1" dur="indefinite" restart="never" nodeType="tmRoot">
-          <p:childTnLst>
-            <p:seq concurrent="1" nextAc="seek">
-              <p:cTn id="2" dur="indefinite" nodeType="mainSeq">
-                <p:childTnLst>
-                  <p:par>
-                    <p:cTn id="3" fill="hold">
-                      <p:stCondLst>
-                        <p:cond delay="0"/>
-                      </p:stCondLst>
-                      <p:childTnLst>
-                        <p:par>
-                          <p:cTn id="4" fill="hold">
-                            <p:stCondLst>
-                              <p:cond delay="0"/>
-                            </p:stCondLst>
-                            <p:childTnLst>
-                              <p:set>
-                                <p:cBhvr>
-                                  <p:cTn id="5" dur="1" fill="hold"/>
-                                  <p:tgtEl>
-                                    <p:spTgt spid="36"/>
-                                  </p:tgtEl>
-                                  <p:attrNameLst>
-                                    <p:attrName>style.visibility</p:attrName>
-                                  </p:attrNameLst>
-                                </p:cBhvr>
-                                <p:to>
-                                  <p:strVal val="hidden"/>
-                                </p:to>
-                              </p:set>
-                              <p:animEffect transition="out" filter="wipe(left)">
-                                <p:cBhvr>
-                                  <p:cTn id="6" dur="75000" fill="hold"/>
-                                  <p:tgtEl>
-                                    <p:spTgt spid="34"/>
-                                  </p:tgtEl>
-                                </p:cBhvr>
-                              </p:animEffect>
-                              <p:animEffect transition="in" filter="fade">
-                                <p:cBhvr>
-                                  <p:cTn id="7" dur="400" fill="hold">
-                                    <p:stCondLst>
-                                      <p:cond delay="75000"/>
-                                    </p:stCondLst>
-                                  </p:cTn>
-                                  <p:tgtEl>
-                                    <p:spTgt spid="36"/>
-                                  </p:tgtEl>
-                                </p:cBhvr>
-                              </p:animEffect>
-                              <p:set>
-                                <p:cBhvr>
-                                  <p:cTn id="8" dur="1" fill="hold">
-                                    <p:stCondLst>
-                                      <p:cond delay="75000"/>
-                                    </p:stCondLst>
-                                  </p:cTn>
-                                  <p:tgtEl>
-                                    <p:spTgt spid="36"/>
-                                  </p:tgtEl>
-                                  <p:attrNameLst>
-                                    <p:attrName>style.visibility</p:attrName>
-                                  </p:attrNameLst>
-                                </p:cBhvr>
-                                <p:to>
-                                  <p:strVal val="visible"/>
-                                </p:to>
-                              </p:set>
-                            </p:childTnLst>
-                          </p:cTn>
-                        </p:par>
-                      </p:childTnLst>
-                    </p:cTn>
-                  </p:par>
-                </p:childTnLst>
-              </p:cTn>
-              <p:prevCondLst>
-                <p:cond evt="onPrev" delay="0">
-                  <p:tgtEl>
-                    <p:sldTgt/>
-                  </p:tgtEl>
-                </p:cond>
-              </p:prevCondLst>
-              <p:nextCondLst>
-                <p:cond evt="onNext" delay="0">
-                  <p:tgtEl>
-                    <p:sldTgt/>
-                  </p:tgtEl>
-                </p:cond>
-              </p:nextCondLst>
-            </p:seq>
-          </p:childTnLst>
-        </p:cTn>
-      </p:par>
-    </p:tnLst>
-  </p:timing>
 </p:sld>
 </file>
 
@@ -11651,7 +9803,7 @@
         <p:spPr>
           <a:xfrm>
             <a:off x="502920" y="438912"/>
-            <a:ext cx="8869680" cy="594360"/>
+            <a:ext cx="11155680" cy="594360"/>
           </a:xfrm>
           <a:prstGeom prst="rect">
             <a:avLst/>
@@ -13414,453 +11566,11 @@
           </a:p>
         </p:txBody>
       </p:sp>
-      <p:sp>
-        <p:nvSpPr>
-          <p:cNvPr id="44" name="Rounded Rectangle 43"/>
-          <p:cNvSpPr/>
-          <p:nvPr/>
-        </p:nvSpPr>
-        <p:spPr>
-          <a:xfrm>
-            <a:off x="9646920" y="164592"/>
-            <a:ext cx="2331720" cy="868680"/>
-          </a:xfrm>
-          <a:prstGeom prst="roundRect">
-            <a:avLst>
-              <a:gd name="adj" fmla="val 12000"/>
-            </a:avLst>
-          </a:prstGeom>
-          <a:solidFill>
-            <a:srgbClr val="1A2332"/>
-          </a:solidFill>
-          <a:ln>
-            <a:noFill/>
-          </a:ln>
-        </p:spPr>
-        <p:style>
-          <a:lnRef idx="1">
-            <a:schemeClr val="accent1"/>
-          </a:lnRef>
-          <a:fillRef idx="3">
-            <a:schemeClr val="accent1"/>
-          </a:fillRef>
-          <a:effectRef idx="2">
-            <a:schemeClr val="accent1"/>
-          </a:effectRef>
-          <a:fontRef idx="minor">
-            <a:schemeClr val="lt1"/>
-          </a:fontRef>
-        </p:style>
-        <p:txBody>
-          <a:bodyPr rtlCol="0" anchor="ctr"/>
-          <a:lstStyle/>
-          <a:p>
-            <a:pPr algn="ctr"/>
-          </a:p>
-        </p:txBody>
-      </p:sp>
-      <p:sp>
-        <p:nvSpPr>
-          <p:cNvPr id="45" name="Rectangle 44"/>
-          <p:cNvSpPr/>
-          <p:nvPr/>
-        </p:nvSpPr>
-        <p:spPr>
-          <a:xfrm>
-            <a:off x="9646920" y="164592"/>
-            <a:ext cx="73152" cy="868680"/>
-          </a:xfrm>
-          <a:prstGeom prst="rect">
-            <a:avLst/>
-          </a:prstGeom>
-          <a:solidFill>
-            <a:srgbClr val="D4A853"/>
-          </a:solidFill>
-          <a:ln>
-            <a:noFill/>
-          </a:ln>
-        </p:spPr>
-        <p:style>
-          <a:lnRef idx="1">
-            <a:schemeClr val="accent1"/>
-          </a:lnRef>
-          <a:fillRef idx="3">
-            <a:schemeClr val="accent1"/>
-          </a:fillRef>
-          <a:effectRef idx="2">
-            <a:schemeClr val="accent1"/>
-          </a:effectRef>
-          <a:fontRef idx="minor">
-            <a:schemeClr val="lt1"/>
-          </a:fontRef>
-        </p:style>
-        <p:txBody>
-          <a:bodyPr rtlCol="0" anchor="ctr"/>
-          <a:lstStyle/>
-          <a:p>
-            <a:pPr algn="ctr"/>
-          </a:p>
-        </p:txBody>
-      </p:sp>
-      <p:sp>
-        <p:nvSpPr>
-          <p:cNvPr id="46" name="TextBox 45"/>
-          <p:cNvSpPr txBox="1"/>
-          <p:nvPr/>
-        </p:nvSpPr>
-        <p:spPr>
-          <a:xfrm>
-            <a:off x="9811512" y="219456"/>
-            <a:ext cx="2075688" cy="777240"/>
-          </a:xfrm>
-          <a:prstGeom prst="rect">
-            <a:avLst/>
-          </a:prstGeom>
-          <a:noFill/>
-        </p:spPr>
-        <p:txBody>
-          <a:bodyPr wrap="square">
-            <a:spAutoFit/>
-          </a:bodyPr>
-          <a:lstStyle/>
-          <a:p>
-            <a:pPr algn="l">
-              <a:spcAft>
-                <a:spcPts val="0"/>
-              </a:spcAft>
-            </a:pPr>
-            <a:r>
-              <a:rPr sz="900" b="1">
-                <a:solidFill>
-                  <a:srgbClr val="8B9CB3"/>
-                </a:solidFill>
-                <a:latin typeface="Calibri"/>
-              </a:rPr>
-              <a:t>SLIDE BUDGET</a:t>
-            </a:r>
-          </a:p>
-          <a:p>
-            <a:pPr algn="l">
-              <a:spcAft>
-                <a:spcPts val="0"/>
-              </a:spcAft>
-            </a:pPr>
-            <a:r>
-              <a:rPr sz="2600" b="1">
-                <a:solidFill>
-                  <a:srgbClr val="D4A853"/>
-                </a:solidFill>
-                <a:latin typeface="Calibri"/>
-              </a:rPr>
-              <a:t>1:00</a:t>
-            </a:r>
-          </a:p>
-          <a:p>
-            <a:pPr algn="l">
-              <a:spcAft>
-                <a:spcPts val="0"/>
-              </a:spcAft>
-            </a:pPr>
-            <a:r>
-              <a:rPr sz="900" b="0">
-                <a:solidFill>
-                  <a:srgbClr val="8B9CB3"/>
-                </a:solidFill>
-                <a:latin typeface="Calibri"/>
-              </a:rPr>
-              <a:t>by end 6:00 · left 4:00</a:t>
-            </a:r>
-          </a:p>
-        </p:txBody>
-      </p:sp>
-      <p:sp>
-        <p:nvSpPr>
-          <p:cNvPr id="47" name="Rounded Rectangle 46"/>
-          <p:cNvSpPr/>
-          <p:nvPr/>
-        </p:nvSpPr>
-        <p:spPr>
-          <a:xfrm>
-            <a:off x="502920" y="5961888"/>
-            <a:ext cx="11155680" cy="109728"/>
-          </a:xfrm>
-          <a:prstGeom prst="roundRect">
-            <a:avLst>
-              <a:gd name="adj" fmla="val 50000"/>
-            </a:avLst>
-          </a:prstGeom>
-          <a:solidFill>
-            <a:srgbClr val="243044"/>
-          </a:solidFill>
-          <a:ln>
-            <a:noFill/>
-          </a:ln>
-        </p:spPr>
-        <p:style>
-          <a:lnRef idx="1">
-            <a:schemeClr val="accent1"/>
-          </a:lnRef>
-          <a:fillRef idx="3">
-            <a:schemeClr val="accent1"/>
-          </a:fillRef>
-          <a:effectRef idx="2">
-            <a:schemeClr val="accent1"/>
-          </a:effectRef>
-          <a:fontRef idx="minor">
-            <a:schemeClr val="lt1"/>
-          </a:fontRef>
-        </p:style>
-        <p:txBody>
-          <a:bodyPr rtlCol="0" anchor="ctr"/>
-          <a:lstStyle/>
-          <a:p>
-            <a:pPr algn="ctr"/>
-          </a:p>
-        </p:txBody>
-      </p:sp>
-      <p:sp>
-        <p:nvSpPr>
-          <p:cNvPr id="48" name="Rounded Rectangle 47"/>
-          <p:cNvSpPr/>
-          <p:nvPr/>
-        </p:nvSpPr>
-        <p:spPr>
-          <a:xfrm>
-            <a:off x="502920" y="5961888"/>
-            <a:ext cx="11155680" cy="109728"/>
-          </a:xfrm>
-          <a:prstGeom prst="roundRect">
-            <a:avLst>
-              <a:gd name="adj" fmla="val 50000"/>
-            </a:avLst>
-          </a:prstGeom>
-          <a:solidFill>
-            <a:srgbClr val="D4A853"/>
-          </a:solidFill>
-          <a:ln>
-            <a:noFill/>
-          </a:ln>
-        </p:spPr>
-        <p:style>
-          <a:lnRef idx="1">
-            <a:schemeClr val="accent1"/>
-          </a:lnRef>
-          <a:fillRef idx="3">
-            <a:schemeClr val="accent1"/>
-          </a:fillRef>
-          <a:effectRef idx="2">
-            <a:schemeClr val="accent1"/>
-          </a:effectRef>
-          <a:fontRef idx="minor">
-            <a:schemeClr val="lt1"/>
-          </a:fontRef>
-        </p:style>
-        <p:txBody>
-          <a:bodyPr rtlCol="0" anchor="ctr"/>
-          <a:lstStyle/>
-          <a:p>
-            <a:pPr algn="ctr"/>
-          </a:p>
-        </p:txBody>
-      </p:sp>
-      <p:sp>
-        <p:nvSpPr>
-          <p:cNvPr id="49" name="TextBox 48"/>
-          <p:cNvSpPr txBox="1"/>
-          <p:nvPr/>
-        </p:nvSpPr>
-        <p:spPr>
-          <a:xfrm>
-            <a:off x="502920" y="5760720"/>
-            <a:ext cx="5029200" cy="201168"/>
-          </a:xfrm>
-          <a:prstGeom prst="rect">
-            <a:avLst/>
-          </a:prstGeom>
-          <a:noFill/>
-        </p:spPr>
-        <p:txBody>
-          <a:bodyPr wrap="none">
-            <a:spAutoFit/>
-          </a:bodyPr>
-          <a:lstStyle/>
-          <a:p>
-            <a:pPr algn="l">
-              <a:spcAft>
-                <a:spcPts val="0"/>
-              </a:spcAft>
-            </a:pPr>
-            <a:r>
-              <a:rPr sz="800" b="0">
-                <a:solidFill>
-                  <a:srgbClr val="8B9CB3"/>
-                </a:solidFill>
-                <a:latin typeface="Calibri"/>
-              </a:rPr>
-              <a:t>Countdown starts in Slideshow · red MOVE ON appears when budget ends · does not auto-advance</a:t>
-            </a:r>
-          </a:p>
-        </p:txBody>
-      </p:sp>
-      <p:sp>
-        <p:nvSpPr>
-          <p:cNvPr id="50" name="Rounded Rectangle 49"/>
-          <p:cNvSpPr/>
-          <p:nvPr/>
-        </p:nvSpPr>
-        <p:spPr>
-          <a:xfrm>
-            <a:off x="9189720" y="5614416"/>
-            <a:ext cx="2468880" cy="292608"/>
-          </a:xfrm>
-          <a:prstGeom prst="roundRect">
-            <a:avLst>
-              <a:gd name="adj" fmla="val 20000"/>
-            </a:avLst>
-          </a:prstGeom>
-          <a:solidFill>
-            <a:srgbClr val="F87171"/>
-          </a:solidFill>
-          <a:ln>
-            <a:noFill/>
-          </a:ln>
-        </p:spPr>
-        <p:style>
-          <a:lnRef idx="1">
-            <a:schemeClr val="accent1"/>
-          </a:lnRef>
-          <a:fillRef idx="3">
-            <a:schemeClr val="accent1"/>
-          </a:fillRef>
-          <a:effectRef idx="2">
-            <a:schemeClr val="accent1"/>
-          </a:effectRef>
-          <a:fontRef idx="minor">
-            <a:schemeClr val="lt1"/>
-          </a:fontRef>
-        </p:style>
-        <p:txBody>
-          <a:bodyPr rtlCol="0" anchor="ctr" wrap="none"/>
-          <a:lstStyle/>
-          <a:p>
-            <a:pPr algn="ctr"/>
-            <a:r>
-              <a:rPr sz="1200" b="1">
-                <a:solidFill>
-                  <a:srgbClr val="E6EDF3"/>
-                </a:solidFill>
-                <a:latin typeface="Calibri"/>
-              </a:rPr>
-              <a:t>MOVE ON  →</a:t>
-            </a:r>
-          </a:p>
-        </p:txBody>
-      </p:sp>
     </p:spTree>
   </p:cSld>
   <p:clrMapOvr>
     <a:masterClrMapping/>
   </p:clrMapOvr>
-  <p:timing>
-    <p:tnLst>
-      <p:par>
-        <p:cTn id="1" dur="indefinite" restart="never" nodeType="tmRoot">
-          <p:childTnLst>
-            <p:seq concurrent="1" nextAc="seek">
-              <p:cTn id="2" dur="indefinite" nodeType="mainSeq">
-                <p:childTnLst>
-                  <p:par>
-                    <p:cTn id="3" fill="hold">
-                      <p:stCondLst>
-                        <p:cond delay="0"/>
-                      </p:stCondLst>
-                      <p:childTnLst>
-                        <p:par>
-                          <p:cTn id="4" fill="hold">
-                            <p:stCondLst>
-                              <p:cond delay="0"/>
-                            </p:stCondLst>
-                            <p:childTnLst>
-                              <p:set>
-                                <p:cBhvr>
-                                  <p:cTn id="5" dur="1" fill="hold"/>
-                                  <p:tgtEl>
-                                    <p:spTgt spid="50"/>
-                                  </p:tgtEl>
-                                  <p:attrNameLst>
-                                    <p:attrName>style.visibility</p:attrName>
-                                  </p:attrNameLst>
-                                </p:cBhvr>
-                                <p:to>
-                                  <p:strVal val="hidden"/>
-                                </p:to>
-                              </p:set>
-                              <p:animEffect transition="out" filter="wipe(left)">
-                                <p:cBhvr>
-                                  <p:cTn id="6" dur="60000" fill="hold"/>
-                                  <p:tgtEl>
-                                    <p:spTgt spid="48"/>
-                                  </p:tgtEl>
-                                </p:cBhvr>
-                              </p:animEffect>
-                              <p:animEffect transition="in" filter="fade">
-                                <p:cBhvr>
-                                  <p:cTn id="7" dur="400" fill="hold">
-                                    <p:stCondLst>
-                                      <p:cond delay="60000"/>
-                                    </p:stCondLst>
-                                  </p:cTn>
-                                  <p:tgtEl>
-                                    <p:spTgt spid="50"/>
-                                  </p:tgtEl>
-                                </p:cBhvr>
-                              </p:animEffect>
-                              <p:set>
-                                <p:cBhvr>
-                                  <p:cTn id="8" dur="1" fill="hold">
-                                    <p:stCondLst>
-                                      <p:cond delay="60000"/>
-                                    </p:stCondLst>
-                                  </p:cTn>
-                                  <p:tgtEl>
-                                    <p:spTgt spid="50"/>
-                                  </p:tgtEl>
-                                  <p:attrNameLst>
-                                    <p:attrName>style.visibility</p:attrName>
-                                  </p:attrNameLst>
-                                </p:cBhvr>
-                                <p:to>
-                                  <p:strVal val="visible"/>
-                                </p:to>
-                              </p:set>
-                            </p:childTnLst>
-                          </p:cTn>
-                        </p:par>
-                      </p:childTnLst>
-                    </p:cTn>
-                  </p:par>
-                </p:childTnLst>
-              </p:cTn>
-              <p:prevCondLst>
-                <p:cond evt="onPrev" delay="0">
-                  <p:tgtEl>
-                    <p:sldTgt/>
-                  </p:tgtEl>
-                </p:cond>
-              </p:prevCondLst>
-              <p:nextCondLst>
-                <p:cond evt="onNext" delay="0">
-                  <p:tgtEl>
-                    <p:sldTgt/>
-                  </p:tgtEl>
-                </p:cond>
-              </p:nextCondLst>
-            </p:seq>
-          </p:childTnLst>
-        </p:cTn>
-      </p:par>
-    </p:tnLst>
-  </p:timing>
 </p:sld>
 </file>
 
@@ -13965,7 +11675,7 @@
         <p:spPr>
           <a:xfrm>
             <a:off x="502920" y="438912"/>
-            <a:ext cx="8869680" cy="594360"/>
+            <a:ext cx="11155680" cy="594360"/>
           </a:xfrm>
           <a:prstGeom prst="rect">
             <a:avLst/>
@@ -15714,453 +13424,11 @@
           </a:p>
         </p:txBody>
       </p:sp>
-      <p:sp>
-        <p:nvSpPr>
-          <p:cNvPr id="40" name="Rounded Rectangle 39"/>
-          <p:cNvSpPr/>
-          <p:nvPr/>
-        </p:nvSpPr>
-        <p:spPr>
-          <a:xfrm>
-            <a:off x="9646920" y="164592"/>
-            <a:ext cx="2331720" cy="868680"/>
-          </a:xfrm>
-          <a:prstGeom prst="roundRect">
-            <a:avLst>
-              <a:gd name="adj" fmla="val 12000"/>
-            </a:avLst>
-          </a:prstGeom>
-          <a:solidFill>
-            <a:srgbClr val="1A2332"/>
-          </a:solidFill>
-          <a:ln>
-            <a:noFill/>
-          </a:ln>
-        </p:spPr>
-        <p:style>
-          <a:lnRef idx="1">
-            <a:schemeClr val="accent1"/>
-          </a:lnRef>
-          <a:fillRef idx="3">
-            <a:schemeClr val="accent1"/>
-          </a:fillRef>
-          <a:effectRef idx="2">
-            <a:schemeClr val="accent1"/>
-          </a:effectRef>
-          <a:fontRef idx="minor">
-            <a:schemeClr val="lt1"/>
-          </a:fontRef>
-        </p:style>
-        <p:txBody>
-          <a:bodyPr rtlCol="0" anchor="ctr"/>
-          <a:lstStyle/>
-          <a:p>
-            <a:pPr algn="ctr"/>
-          </a:p>
-        </p:txBody>
-      </p:sp>
-      <p:sp>
-        <p:nvSpPr>
-          <p:cNvPr id="41" name="Rectangle 40"/>
-          <p:cNvSpPr/>
-          <p:nvPr/>
-        </p:nvSpPr>
-        <p:spPr>
-          <a:xfrm>
-            <a:off x="9646920" y="164592"/>
-            <a:ext cx="73152" cy="868680"/>
-          </a:xfrm>
-          <a:prstGeom prst="rect">
-            <a:avLst/>
-          </a:prstGeom>
-          <a:solidFill>
-            <a:srgbClr val="D4A853"/>
-          </a:solidFill>
-          <a:ln>
-            <a:noFill/>
-          </a:ln>
-        </p:spPr>
-        <p:style>
-          <a:lnRef idx="1">
-            <a:schemeClr val="accent1"/>
-          </a:lnRef>
-          <a:fillRef idx="3">
-            <a:schemeClr val="accent1"/>
-          </a:fillRef>
-          <a:effectRef idx="2">
-            <a:schemeClr val="accent1"/>
-          </a:effectRef>
-          <a:fontRef idx="minor">
-            <a:schemeClr val="lt1"/>
-          </a:fontRef>
-        </p:style>
-        <p:txBody>
-          <a:bodyPr rtlCol="0" anchor="ctr"/>
-          <a:lstStyle/>
-          <a:p>
-            <a:pPr algn="ctr"/>
-          </a:p>
-        </p:txBody>
-      </p:sp>
-      <p:sp>
-        <p:nvSpPr>
-          <p:cNvPr id="42" name="TextBox 41"/>
-          <p:cNvSpPr txBox="1"/>
-          <p:nvPr/>
-        </p:nvSpPr>
-        <p:spPr>
-          <a:xfrm>
-            <a:off x="9811512" y="219456"/>
-            <a:ext cx="2075688" cy="777240"/>
-          </a:xfrm>
-          <a:prstGeom prst="rect">
-            <a:avLst/>
-          </a:prstGeom>
-          <a:noFill/>
-        </p:spPr>
-        <p:txBody>
-          <a:bodyPr wrap="square">
-            <a:spAutoFit/>
-          </a:bodyPr>
-          <a:lstStyle/>
-          <a:p>
-            <a:pPr algn="l">
-              <a:spcAft>
-                <a:spcPts val="0"/>
-              </a:spcAft>
-            </a:pPr>
-            <a:r>
-              <a:rPr sz="900" b="1">
-                <a:solidFill>
-                  <a:srgbClr val="8B9CB3"/>
-                </a:solidFill>
-                <a:latin typeface="Calibri"/>
-              </a:rPr>
-              <a:t>SLIDE BUDGET</a:t>
-            </a:r>
-          </a:p>
-          <a:p>
-            <a:pPr algn="l">
-              <a:spcAft>
-                <a:spcPts val="0"/>
-              </a:spcAft>
-            </a:pPr>
-            <a:r>
-              <a:rPr sz="2600" b="1">
-                <a:solidFill>
-                  <a:srgbClr val="D4A853"/>
-                </a:solidFill>
-                <a:latin typeface="Calibri"/>
-              </a:rPr>
-              <a:t>1:15</a:t>
-            </a:r>
-          </a:p>
-          <a:p>
-            <a:pPr algn="l">
-              <a:spcAft>
-                <a:spcPts val="0"/>
-              </a:spcAft>
-            </a:pPr>
-            <a:r>
-              <a:rPr sz="900" b="0">
-                <a:solidFill>
-                  <a:srgbClr val="8B9CB3"/>
-                </a:solidFill>
-                <a:latin typeface="Calibri"/>
-              </a:rPr>
-              <a:t>by end 7:15 · left 2:45</a:t>
-            </a:r>
-          </a:p>
-        </p:txBody>
-      </p:sp>
-      <p:sp>
-        <p:nvSpPr>
-          <p:cNvPr id="43" name="Rounded Rectangle 42"/>
-          <p:cNvSpPr/>
-          <p:nvPr/>
-        </p:nvSpPr>
-        <p:spPr>
-          <a:xfrm>
-            <a:off x="502920" y="5961888"/>
-            <a:ext cx="11155680" cy="109728"/>
-          </a:xfrm>
-          <a:prstGeom prst="roundRect">
-            <a:avLst>
-              <a:gd name="adj" fmla="val 50000"/>
-            </a:avLst>
-          </a:prstGeom>
-          <a:solidFill>
-            <a:srgbClr val="243044"/>
-          </a:solidFill>
-          <a:ln>
-            <a:noFill/>
-          </a:ln>
-        </p:spPr>
-        <p:style>
-          <a:lnRef idx="1">
-            <a:schemeClr val="accent1"/>
-          </a:lnRef>
-          <a:fillRef idx="3">
-            <a:schemeClr val="accent1"/>
-          </a:fillRef>
-          <a:effectRef idx="2">
-            <a:schemeClr val="accent1"/>
-          </a:effectRef>
-          <a:fontRef idx="minor">
-            <a:schemeClr val="lt1"/>
-          </a:fontRef>
-        </p:style>
-        <p:txBody>
-          <a:bodyPr rtlCol="0" anchor="ctr"/>
-          <a:lstStyle/>
-          <a:p>
-            <a:pPr algn="ctr"/>
-          </a:p>
-        </p:txBody>
-      </p:sp>
-      <p:sp>
-        <p:nvSpPr>
-          <p:cNvPr id="44" name="Rounded Rectangle 43"/>
-          <p:cNvSpPr/>
-          <p:nvPr/>
-        </p:nvSpPr>
-        <p:spPr>
-          <a:xfrm>
-            <a:off x="502920" y="5961888"/>
-            <a:ext cx="11155680" cy="109728"/>
-          </a:xfrm>
-          <a:prstGeom prst="roundRect">
-            <a:avLst>
-              <a:gd name="adj" fmla="val 50000"/>
-            </a:avLst>
-          </a:prstGeom>
-          <a:solidFill>
-            <a:srgbClr val="D4A853"/>
-          </a:solidFill>
-          <a:ln>
-            <a:noFill/>
-          </a:ln>
-        </p:spPr>
-        <p:style>
-          <a:lnRef idx="1">
-            <a:schemeClr val="accent1"/>
-          </a:lnRef>
-          <a:fillRef idx="3">
-            <a:schemeClr val="accent1"/>
-          </a:fillRef>
-          <a:effectRef idx="2">
-            <a:schemeClr val="accent1"/>
-          </a:effectRef>
-          <a:fontRef idx="minor">
-            <a:schemeClr val="lt1"/>
-          </a:fontRef>
-        </p:style>
-        <p:txBody>
-          <a:bodyPr rtlCol="0" anchor="ctr"/>
-          <a:lstStyle/>
-          <a:p>
-            <a:pPr algn="ctr"/>
-          </a:p>
-        </p:txBody>
-      </p:sp>
-      <p:sp>
-        <p:nvSpPr>
-          <p:cNvPr id="45" name="TextBox 44"/>
-          <p:cNvSpPr txBox="1"/>
-          <p:nvPr/>
-        </p:nvSpPr>
-        <p:spPr>
-          <a:xfrm>
-            <a:off x="502920" y="5760720"/>
-            <a:ext cx="5029200" cy="201168"/>
-          </a:xfrm>
-          <a:prstGeom prst="rect">
-            <a:avLst/>
-          </a:prstGeom>
-          <a:noFill/>
-        </p:spPr>
-        <p:txBody>
-          <a:bodyPr wrap="none">
-            <a:spAutoFit/>
-          </a:bodyPr>
-          <a:lstStyle/>
-          <a:p>
-            <a:pPr algn="l">
-              <a:spcAft>
-                <a:spcPts val="0"/>
-              </a:spcAft>
-            </a:pPr>
-            <a:r>
-              <a:rPr sz="800" b="0">
-                <a:solidFill>
-                  <a:srgbClr val="8B9CB3"/>
-                </a:solidFill>
-                <a:latin typeface="Calibri"/>
-              </a:rPr>
-              <a:t>Countdown starts in Slideshow · red MOVE ON appears when budget ends · does not auto-advance</a:t>
-            </a:r>
-          </a:p>
-        </p:txBody>
-      </p:sp>
-      <p:sp>
-        <p:nvSpPr>
-          <p:cNvPr id="46" name="Rounded Rectangle 45"/>
-          <p:cNvSpPr/>
-          <p:nvPr/>
-        </p:nvSpPr>
-        <p:spPr>
-          <a:xfrm>
-            <a:off x="9189720" y="5614416"/>
-            <a:ext cx="2468880" cy="292608"/>
-          </a:xfrm>
-          <a:prstGeom prst="roundRect">
-            <a:avLst>
-              <a:gd name="adj" fmla="val 20000"/>
-            </a:avLst>
-          </a:prstGeom>
-          <a:solidFill>
-            <a:srgbClr val="F87171"/>
-          </a:solidFill>
-          <a:ln>
-            <a:noFill/>
-          </a:ln>
-        </p:spPr>
-        <p:style>
-          <a:lnRef idx="1">
-            <a:schemeClr val="accent1"/>
-          </a:lnRef>
-          <a:fillRef idx="3">
-            <a:schemeClr val="accent1"/>
-          </a:fillRef>
-          <a:effectRef idx="2">
-            <a:schemeClr val="accent1"/>
-          </a:effectRef>
-          <a:fontRef idx="minor">
-            <a:schemeClr val="lt1"/>
-          </a:fontRef>
-        </p:style>
-        <p:txBody>
-          <a:bodyPr rtlCol="0" anchor="ctr" wrap="none"/>
-          <a:lstStyle/>
-          <a:p>
-            <a:pPr algn="ctr"/>
-            <a:r>
-              <a:rPr sz="1200" b="1">
-                <a:solidFill>
-                  <a:srgbClr val="E6EDF3"/>
-                </a:solidFill>
-                <a:latin typeface="Calibri"/>
-              </a:rPr>
-              <a:t>MOVE ON  →</a:t>
-            </a:r>
-          </a:p>
-        </p:txBody>
-      </p:sp>
     </p:spTree>
   </p:cSld>
   <p:clrMapOvr>
     <a:masterClrMapping/>
   </p:clrMapOvr>
-  <p:timing>
-    <p:tnLst>
-      <p:par>
-        <p:cTn id="1" dur="indefinite" restart="never" nodeType="tmRoot">
-          <p:childTnLst>
-            <p:seq concurrent="1" nextAc="seek">
-              <p:cTn id="2" dur="indefinite" nodeType="mainSeq">
-                <p:childTnLst>
-                  <p:par>
-                    <p:cTn id="3" fill="hold">
-                      <p:stCondLst>
-                        <p:cond delay="0"/>
-                      </p:stCondLst>
-                      <p:childTnLst>
-                        <p:par>
-                          <p:cTn id="4" fill="hold">
-                            <p:stCondLst>
-                              <p:cond delay="0"/>
-                            </p:stCondLst>
-                            <p:childTnLst>
-                              <p:set>
-                                <p:cBhvr>
-                                  <p:cTn id="5" dur="1" fill="hold"/>
-                                  <p:tgtEl>
-                                    <p:spTgt spid="46"/>
-                                  </p:tgtEl>
-                                  <p:attrNameLst>
-                                    <p:attrName>style.visibility</p:attrName>
-                                  </p:attrNameLst>
-                                </p:cBhvr>
-                                <p:to>
-                                  <p:strVal val="hidden"/>
-                                </p:to>
-                              </p:set>
-                              <p:animEffect transition="out" filter="wipe(left)">
-                                <p:cBhvr>
-                                  <p:cTn id="6" dur="75000" fill="hold"/>
-                                  <p:tgtEl>
-                                    <p:spTgt spid="44"/>
-                                  </p:tgtEl>
-                                </p:cBhvr>
-                              </p:animEffect>
-                              <p:animEffect transition="in" filter="fade">
-                                <p:cBhvr>
-                                  <p:cTn id="7" dur="400" fill="hold">
-                                    <p:stCondLst>
-                                      <p:cond delay="75000"/>
-                                    </p:stCondLst>
-                                  </p:cTn>
-                                  <p:tgtEl>
-                                    <p:spTgt spid="46"/>
-                                  </p:tgtEl>
-                                </p:cBhvr>
-                              </p:animEffect>
-                              <p:set>
-                                <p:cBhvr>
-                                  <p:cTn id="8" dur="1" fill="hold">
-                                    <p:stCondLst>
-                                      <p:cond delay="75000"/>
-                                    </p:stCondLst>
-                                  </p:cTn>
-                                  <p:tgtEl>
-                                    <p:spTgt spid="46"/>
-                                  </p:tgtEl>
-                                  <p:attrNameLst>
-                                    <p:attrName>style.visibility</p:attrName>
-                                  </p:attrNameLst>
-                                </p:cBhvr>
-                                <p:to>
-                                  <p:strVal val="visible"/>
-                                </p:to>
-                              </p:set>
-                            </p:childTnLst>
-                          </p:cTn>
-                        </p:par>
-                      </p:childTnLst>
-                    </p:cTn>
-                  </p:par>
-                </p:childTnLst>
-              </p:cTn>
-              <p:prevCondLst>
-                <p:cond evt="onPrev" delay="0">
-                  <p:tgtEl>
-                    <p:sldTgt/>
-                  </p:tgtEl>
-                </p:cond>
-              </p:prevCondLst>
-              <p:nextCondLst>
-                <p:cond evt="onNext" delay="0">
-                  <p:tgtEl>
-                    <p:sldTgt/>
-                  </p:tgtEl>
-                </p:cond>
-              </p:nextCondLst>
-            </p:seq>
-          </p:childTnLst>
-        </p:cTn>
-      </p:par>
-    </p:tnLst>
-  </p:timing>
 </p:sld>
 </file>
 
@@ -16265,7 +13533,7 @@
         <p:spPr>
           <a:xfrm>
             <a:off x="502920" y="438912"/>
-            <a:ext cx="8869680" cy="594360"/>
+            <a:ext cx="11155680" cy="594360"/>
           </a:xfrm>
           <a:prstGeom prst="rect">
             <a:avLst/>
@@ -18330,453 +15598,11 @@
           </a:p>
         </p:txBody>
       </p:sp>
-      <p:sp>
-        <p:nvSpPr>
-          <p:cNvPr id="46" name="Rounded Rectangle 45"/>
-          <p:cNvSpPr/>
-          <p:nvPr/>
-        </p:nvSpPr>
-        <p:spPr>
-          <a:xfrm>
-            <a:off x="9646920" y="164592"/>
-            <a:ext cx="2331720" cy="868680"/>
-          </a:xfrm>
-          <a:prstGeom prst="roundRect">
-            <a:avLst>
-              <a:gd name="adj" fmla="val 12000"/>
-            </a:avLst>
-          </a:prstGeom>
-          <a:solidFill>
-            <a:srgbClr val="1A2332"/>
-          </a:solidFill>
-          <a:ln>
-            <a:noFill/>
-          </a:ln>
-        </p:spPr>
-        <p:style>
-          <a:lnRef idx="1">
-            <a:schemeClr val="accent1"/>
-          </a:lnRef>
-          <a:fillRef idx="3">
-            <a:schemeClr val="accent1"/>
-          </a:fillRef>
-          <a:effectRef idx="2">
-            <a:schemeClr val="accent1"/>
-          </a:effectRef>
-          <a:fontRef idx="minor">
-            <a:schemeClr val="lt1"/>
-          </a:fontRef>
-        </p:style>
-        <p:txBody>
-          <a:bodyPr rtlCol="0" anchor="ctr"/>
-          <a:lstStyle/>
-          <a:p>
-            <a:pPr algn="ctr"/>
-          </a:p>
-        </p:txBody>
-      </p:sp>
-      <p:sp>
-        <p:nvSpPr>
-          <p:cNvPr id="47" name="Rectangle 46"/>
-          <p:cNvSpPr/>
-          <p:nvPr/>
-        </p:nvSpPr>
-        <p:spPr>
-          <a:xfrm>
-            <a:off x="9646920" y="164592"/>
-            <a:ext cx="73152" cy="868680"/>
-          </a:xfrm>
-          <a:prstGeom prst="rect">
-            <a:avLst/>
-          </a:prstGeom>
-          <a:solidFill>
-            <a:srgbClr val="D4A853"/>
-          </a:solidFill>
-          <a:ln>
-            <a:noFill/>
-          </a:ln>
-        </p:spPr>
-        <p:style>
-          <a:lnRef idx="1">
-            <a:schemeClr val="accent1"/>
-          </a:lnRef>
-          <a:fillRef idx="3">
-            <a:schemeClr val="accent1"/>
-          </a:fillRef>
-          <a:effectRef idx="2">
-            <a:schemeClr val="accent1"/>
-          </a:effectRef>
-          <a:fontRef idx="minor">
-            <a:schemeClr val="lt1"/>
-          </a:fontRef>
-        </p:style>
-        <p:txBody>
-          <a:bodyPr rtlCol="0" anchor="ctr"/>
-          <a:lstStyle/>
-          <a:p>
-            <a:pPr algn="ctr"/>
-          </a:p>
-        </p:txBody>
-      </p:sp>
-      <p:sp>
-        <p:nvSpPr>
-          <p:cNvPr id="48" name="TextBox 47"/>
-          <p:cNvSpPr txBox="1"/>
-          <p:nvPr/>
-        </p:nvSpPr>
-        <p:spPr>
-          <a:xfrm>
-            <a:off x="9811512" y="219456"/>
-            <a:ext cx="2075688" cy="777240"/>
-          </a:xfrm>
-          <a:prstGeom prst="rect">
-            <a:avLst/>
-          </a:prstGeom>
-          <a:noFill/>
-        </p:spPr>
-        <p:txBody>
-          <a:bodyPr wrap="square">
-            <a:spAutoFit/>
-          </a:bodyPr>
-          <a:lstStyle/>
-          <a:p>
-            <a:pPr algn="l">
-              <a:spcAft>
-                <a:spcPts val="0"/>
-              </a:spcAft>
-            </a:pPr>
-            <a:r>
-              <a:rPr sz="900" b="1">
-                <a:solidFill>
-                  <a:srgbClr val="8B9CB3"/>
-                </a:solidFill>
-                <a:latin typeface="Calibri"/>
-              </a:rPr>
-              <a:t>SLIDE BUDGET</a:t>
-            </a:r>
-          </a:p>
-          <a:p>
-            <a:pPr algn="l">
-              <a:spcAft>
-                <a:spcPts val="0"/>
-              </a:spcAft>
-            </a:pPr>
-            <a:r>
-              <a:rPr sz="2600" b="1">
-                <a:solidFill>
-                  <a:srgbClr val="D4A853"/>
-                </a:solidFill>
-                <a:latin typeface="Calibri"/>
-              </a:rPr>
-              <a:t>1:30</a:t>
-            </a:r>
-          </a:p>
-          <a:p>
-            <a:pPr algn="l">
-              <a:spcAft>
-                <a:spcPts val="0"/>
-              </a:spcAft>
-            </a:pPr>
-            <a:r>
-              <a:rPr sz="900" b="0">
-                <a:solidFill>
-                  <a:srgbClr val="8B9CB3"/>
-                </a:solidFill>
-                <a:latin typeface="Calibri"/>
-              </a:rPr>
-              <a:t>by end 8:45 · left 1:15</a:t>
-            </a:r>
-          </a:p>
-        </p:txBody>
-      </p:sp>
-      <p:sp>
-        <p:nvSpPr>
-          <p:cNvPr id="49" name="Rounded Rectangle 48"/>
-          <p:cNvSpPr/>
-          <p:nvPr/>
-        </p:nvSpPr>
-        <p:spPr>
-          <a:xfrm>
-            <a:off x="502920" y="5961888"/>
-            <a:ext cx="11155680" cy="109728"/>
-          </a:xfrm>
-          <a:prstGeom prst="roundRect">
-            <a:avLst>
-              <a:gd name="adj" fmla="val 50000"/>
-            </a:avLst>
-          </a:prstGeom>
-          <a:solidFill>
-            <a:srgbClr val="243044"/>
-          </a:solidFill>
-          <a:ln>
-            <a:noFill/>
-          </a:ln>
-        </p:spPr>
-        <p:style>
-          <a:lnRef idx="1">
-            <a:schemeClr val="accent1"/>
-          </a:lnRef>
-          <a:fillRef idx="3">
-            <a:schemeClr val="accent1"/>
-          </a:fillRef>
-          <a:effectRef idx="2">
-            <a:schemeClr val="accent1"/>
-          </a:effectRef>
-          <a:fontRef idx="minor">
-            <a:schemeClr val="lt1"/>
-          </a:fontRef>
-        </p:style>
-        <p:txBody>
-          <a:bodyPr rtlCol="0" anchor="ctr"/>
-          <a:lstStyle/>
-          <a:p>
-            <a:pPr algn="ctr"/>
-          </a:p>
-        </p:txBody>
-      </p:sp>
-      <p:sp>
-        <p:nvSpPr>
-          <p:cNvPr id="50" name="Rounded Rectangle 49"/>
-          <p:cNvSpPr/>
-          <p:nvPr/>
-        </p:nvSpPr>
-        <p:spPr>
-          <a:xfrm>
-            <a:off x="502920" y="5961888"/>
-            <a:ext cx="11155680" cy="109728"/>
-          </a:xfrm>
-          <a:prstGeom prst="roundRect">
-            <a:avLst>
-              <a:gd name="adj" fmla="val 50000"/>
-            </a:avLst>
-          </a:prstGeom>
-          <a:solidFill>
-            <a:srgbClr val="D4A853"/>
-          </a:solidFill>
-          <a:ln>
-            <a:noFill/>
-          </a:ln>
-        </p:spPr>
-        <p:style>
-          <a:lnRef idx="1">
-            <a:schemeClr val="accent1"/>
-          </a:lnRef>
-          <a:fillRef idx="3">
-            <a:schemeClr val="accent1"/>
-          </a:fillRef>
-          <a:effectRef idx="2">
-            <a:schemeClr val="accent1"/>
-          </a:effectRef>
-          <a:fontRef idx="minor">
-            <a:schemeClr val="lt1"/>
-          </a:fontRef>
-        </p:style>
-        <p:txBody>
-          <a:bodyPr rtlCol="0" anchor="ctr"/>
-          <a:lstStyle/>
-          <a:p>
-            <a:pPr algn="ctr"/>
-          </a:p>
-        </p:txBody>
-      </p:sp>
-      <p:sp>
-        <p:nvSpPr>
-          <p:cNvPr id="51" name="TextBox 50"/>
-          <p:cNvSpPr txBox="1"/>
-          <p:nvPr/>
-        </p:nvSpPr>
-        <p:spPr>
-          <a:xfrm>
-            <a:off x="502920" y="5760720"/>
-            <a:ext cx="5029200" cy="201168"/>
-          </a:xfrm>
-          <a:prstGeom prst="rect">
-            <a:avLst/>
-          </a:prstGeom>
-          <a:noFill/>
-        </p:spPr>
-        <p:txBody>
-          <a:bodyPr wrap="none">
-            <a:spAutoFit/>
-          </a:bodyPr>
-          <a:lstStyle/>
-          <a:p>
-            <a:pPr algn="l">
-              <a:spcAft>
-                <a:spcPts val="0"/>
-              </a:spcAft>
-            </a:pPr>
-            <a:r>
-              <a:rPr sz="800" b="0">
-                <a:solidFill>
-                  <a:srgbClr val="8B9CB3"/>
-                </a:solidFill>
-                <a:latin typeface="Calibri"/>
-              </a:rPr>
-              <a:t>Countdown starts in Slideshow · red MOVE ON appears when budget ends · does not auto-advance</a:t>
-            </a:r>
-          </a:p>
-        </p:txBody>
-      </p:sp>
-      <p:sp>
-        <p:nvSpPr>
-          <p:cNvPr id="52" name="Rounded Rectangle 51"/>
-          <p:cNvSpPr/>
-          <p:nvPr/>
-        </p:nvSpPr>
-        <p:spPr>
-          <a:xfrm>
-            <a:off x="9189720" y="5614416"/>
-            <a:ext cx="2468880" cy="292608"/>
-          </a:xfrm>
-          <a:prstGeom prst="roundRect">
-            <a:avLst>
-              <a:gd name="adj" fmla="val 20000"/>
-            </a:avLst>
-          </a:prstGeom>
-          <a:solidFill>
-            <a:srgbClr val="F87171"/>
-          </a:solidFill>
-          <a:ln>
-            <a:noFill/>
-          </a:ln>
-        </p:spPr>
-        <p:style>
-          <a:lnRef idx="1">
-            <a:schemeClr val="accent1"/>
-          </a:lnRef>
-          <a:fillRef idx="3">
-            <a:schemeClr val="accent1"/>
-          </a:fillRef>
-          <a:effectRef idx="2">
-            <a:schemeClr val="accent1"/>
-          </a:effectRef>
-          <a:fontRef idx="minor">
-            <a:schemeClr val="lt1"/>
-          </a:fontRef>
-        </p:style>
-        <p:txBody>
-          <a:bodyPr rtlCol="0" anchor="ctr" wrap="none"/>
-          <a:lstStyle/>
-          <a:p>
-            <a:pPr algn="ctr"/>
-            <a:r>
-              <a:rPr sz="1200" b="1">
-                <a:solidFill>
-                  <a:srgbClr val="E6EDF3"/>
-                </a:solidFill>
-                <a:latin typeface="Calibri"/>
-              </a:rPr>
-              <a:t>MOVE ON  →</a:t>
-            </a:r>
-          </a:p>
-        </p:txBody>
-      </p:sp>
     </p:spTree>
   </p:cSld>
   <p:clrMapOvr>
     <a:masterClrMapping/>
   </p:clrMapOvr>
-  <p:timing>
-    <p:tnLst>
-      <p:par>
-        <p:cTn id="1" dur="indefinite" restart="never" nodeType="tmRoot">
-          <p:childTnLst>
-            <p:seq concurrent="1" nextAc="seek">
-              <p:cTn id="2" dur="indefinite" nodeType="mainSeq">
-                <p:childTnLst>
-                  <p:par>
-                    <p:cTn id="3" fill="hold">
-                      <p:stCondLst>
-                        <p:cond delay="0"/>
-                      </p:stCondLst>
-                      <p:childTnLst>
-                        <p:par>
-                          <p:cTn id="4" fill="hold">
-                            <p:stCondLst>
-                              <p:cond delay="0"/>
-                            </p:stCondLst>
-                            <p:childTnLst>
-                              <p:set>
-                                <p:cBhvr>
-                                  <p:cTn id="5" dur="1" fill="hold"/>
-                                  <p:tgtEl>
-                                    <p:spTgt spid="52"/>
-                                  </p:tgtEl>
-                                  <p:attrNameLst>
-                                    <p:attrName>style.visibility</p:attrName>
-                                  </p:attrNameLst>
-                                </p:cBhvr>
-                                <p:to>
-                                  <p:strVal val="hidden"/>
-                                </p:to>
-                              </p:set>
-                              <p:animEffect transition="out" filter="wipe(left)">
-                                <p:cBhvr>
-                                  <p:cTn id="6" dur="90000" fill="hold"/>
-                                  <p:tgtEl>
-                                    <p:spTgt spid="50"/>
-                                  </p:tgtEl>
-                                </p:cBhvr>
-                              </p:animEffect>
-                              <p:animEffect transition="in" filter="fade">
-                                <p:cBhvr>
-                                  <p:cTn id="7" dur="400" fill="hold">
-                                    <p:stCondLst>
-                                      <p:cond delay="90000"/>
-                                    </p:stCondLst>
-                                  </p:cTn>
-                                  <p:tgtEl>
-                                    <p:spTgt spid="52"/>
-                                  </p:tgtEl>
-                                </p:cBhvr>
-                              </p:animEffect>
-                              <p:set>
-                                <p:cBhvr>
-                                  <p:cTn id="8" dur="1" fill="hold">
-                                    <p:stCondLst>
-                                      <p:cond delay="90000"/>
-                                    </p:stCondLst>
-                                  </p:cTn>
-                                  <p:tgtEl>
-                                    <p:spTgt spid="52"/>
-                                  </p:tgtEl>
-                                  <p:attrNameLst>
-                                    <p:attrName>style.visibility</p:attrName>
-                                  </p:attrNameLst>
-                                </p:cBhvr>
-                                <p:to>
-                                  <p:strVal val="visible"/>
-                                </p:to>
-                              </p:set>
-                            </p:childTnLst>
-                          </p:cTn>
-                        </p:par>
-                      </p:childTnLst>
-                    </p:cTn>
-                  </p:par>
-                </p:childTnLst>
-              </p:cTn>
-              <p:prevCondLst>
-                <p:cond evt="onPrev" delay="0">
-                  <p:tgtEl>
-                    <p:sldTgt/>
-                  </p:tgtEl>
-                </p:cond>
-              </p:prevCondLst>
-              <p:nextCondLst>
-                <p:cond evt="onNext" delay="0">
-                  <p:tgtEl>
-                    <p:sldTgt/>
-                  </p:tgtEl>
-                </p:cond>
-              </p:nextCondLst>
-            </p:seq>
-          </p:childTnLst>
-        </p:cTn>
-      </p:par>
-    </p:tnLst>
-  </p:timing>
 </p:sld>
 </file>
 
@@ -18881,7 +15707,7 @@
         <p:spPr>
           <a:xfrm>
             <a:off x="502920" y="438912"/>
-            <a:ext cx="8869680" cy="594360"/>
+            <a:ext cx="11155680" cy="594360"/>
           </a:xfrm>
           <a:prstGeom prst="rect">
             <a:avLst/>
@@ -20150,453 +16976,11 @@
           </a:p>
         </p:txBody>
       </p:sp>
-      <p:sp>
-        <p:nvSpPr>
-          <p:cNvPr id="32" name="Rounded Rectangle 31"/>
-          <p:cNvSpPr/>
-          <p:nvPr/>
-        </p:nvSpPr>
-        <p:spPr>
-          <a:xfrm>
-            <a:off x="9646920" y="164592"/>
-            <a:ext cx="2331720" cy="868680"/>
-          </a:xfrm>
-          <a:prstGeom prst="roundRect">
-            <a:avLst>
-              <a:gd name="adj" fmla="val 12000"/>
-            </a:avLst>
-          </a:prstGeom>
-          <a:solidFill>
-            <a:srgbClr val="1A2332"/>
-          </a:solidFill>
-          <a:ln>
-            <a:noFill/>
-          </a:ln>
-        </p:spPr>
-        <p:style>
-          <a:lnRef idx="1">
-            <a:schemeClr val="accent1"/>
-          </a:lnRef>
-          <a:fillRef idx="3">
-            <a:schemeClr val="accent1"/>
-          </a:fillRef>
-          <a:effectRef idx="2">
-            <a:schemeClr val="accent1"/>
-          </a:effectRef>
-          <a:fontRef idx="minor">
-            <a:schemeClr val="lt1"/>
-          </a:fontRef>
-        </p:style>
-        <p:txBody>
-          <a:bodyPr rtlCol="0" anchor="ctr"/>
-          <a:lstStyle/>
-          <a:p>
-            <a:pPr algn="ctr"/>
-          </a:p>
-        </p:txBody>
-      </p:sp>
-      <p:sp>
-        <p:nvSpPr>
-          <p:cNvPr id="33" name="Rectangle 32"/>
-          <p:cNvSpPr/>
-          <p:nvPr/>
-        </p:nvSpPr>
-        <p:spPr>
-          <a:xfrm>
-            <a:off x="9646920" y="164592"/>
-            <a:ext cx="73152" cy="868680"/>
-          </a:xfrm>
-          <a:prstGeom prst="rect">
-            <a:avLst/>
-          </a:prstGeom>
-          <a:solidFill>
-            <a:srgbClr val="D4A853"/>
-          </a:solidFill>
-          <a:ln>
-            <a:noFill/>
-          </a:ln>
-        </p:spPr>
-        <p:style>
-          <a:lnRef idx="1">
-            <a:schemeClr val="accent1"/>
-          </a:lnRef>
-          <a:fillRef idx="3">
-            <a:schemeClr val="accent1"/>
-          </a:fillRef>
-          <a:effectRef idx="2">
-            <a:schemeClr val="accent1"/>
-          </a:effectRef>
-          <a:fontRef idx="minor">
-            <a:schemeClr val="lt1"/>
-          </a:fontRef>
-        </p:style>
-        <p:txBody>
-          <a:bodyPr rtlCol="0" anchor="ctr"/>
-          <a:lstStyle/>
-          <a:p>
-            <a:pPr algn="ctr"/>
-          </a:p>
-        </p:txBody>
-      </p:sp>
-      <p:sp>
-        <p:nvSpPr>
-          <p:cNvPr id="34" name="TextBox 33"/>
-          <p:cNvSpPr txBox="1"/>
-          <p:nvPr/>
-        </p:nvSpPr>
-        <p:spPr>
-          <a:xfrm>
-            <a:off x="9811512" y="219456"/>
-            <a:ext cx="2075688" cy="777240"/>
-          </a:xfrm>
-          <a:prstGeom prst="rect">
-            <a:avLst/>
-          </a:prstGeom>
-          <a:noFill/>
-        </p:spPr>
-        <p:txBody>
-          <a:bodyPr wrap="square">
-            <a:spAutoFit/>
-          </a:bodyPr>
-          <a:lstStyle/>
-          <a:p>
-            <a:pPr algn="l">
-              <a:spcAft>
-                <a:spcPts val="0"/>
-              </a:spcAft>
-            </a:pPr>
-            <a:r>
-              <a:rPr sz="900" b="1">
-                <a:solidFill>
-                  <a:srgbClr val="8B9CB3"/>
-                </a:solidFill>
-                <a:latin typeface="Calibri"/>
-              </a:rPr>
-              <a:t>SLIDE BUDGET</a:t>
-            </a:r>
-          </a:p>
-          <a:p>
-            <a:pPr algn="l">
-              <a:spcAft>
-                <a:spcPts val="0"/>
-              </a:spcAft>
-            </a:pPr>
-            <a:r>
-              <a:rPr sz="2600" b="1">
-                <a:solidFill>
-                  <a:srgbClr val="D4A853"/>
-                </a:solidFill>
-                <a:latin typeface="Calibri"/>
-              </a:rPr>
-              <a:t>1:15</a:t>
-            </a:r>
-          </a:p>
-          <a:p>
-            <a:pPr algn="l">
-              <a:spcAft>
-                <a:spcPts val="0"/>
-              </a:spcAft>
-            </a:pPr>
-            <a:r>
-              <a:rPr sz="900" b="0">
-                <a:solidFill>
-                  <a:srgbClr val="8B9CB3"/>
-                </a:solidFill>
-                <a:latin typeface="Calibri"/>
-              </a:rPr>
-              <a:t>by end 10:00 · left 0:00</a:t>
-            </a:r>
-          </a:p>
-        </p:txBody>
-      </p:sp>
-      <p:sp>
-        <p:nvSpPr>
-          <p:cNvPr id="35" name="Rounded Rectangle 34"/>
-          <p:cNvSpPr/>
-          <p:nvPr/>
-        </p:nvSpPr>
-        <p:spPr>
-          <a:xfrm>
-            <a:off x="502920" y="5961888"/>
-            <a:ext cx="11155680" cy="109728"/>
-          </a:xfrm>
-          <a:prstGeom prst="roundRect">
-            <a:avLst>
-              <a:gd name="adj" fmla="val 50000"/>
-            </a:avLst>
-          </a:prstGeom>
-          <a:solidFill>
-            <a:srgbClr val="243044"/>
-          </a:solidFill>
-          <a:ln>
-            <a:noFill/>
-          </a:ln>
-        </p:spPr>
-        <p:style>
-          <a:lnRef idx="1">
-            <a:schemeClr val="accent1"/>
-          </a:lnRef>
-          <a:fillRef idx="3">
-            <a:schemeClr val="accent1"/>
-          </a:fillRef>
-          <a:effectRef idx="2">
-            <a:schemeClr val="accent1"/>
-          </a:effectRef>
-          <a:fontRef idx="minor">
-            <a:schemeClr val="lt1"/>
-          </a:fontRef>
-        </p:style>
-        <p:txBody>
-          <a:bodyPr rtlCol="0" anchor="ctr"/>
-          <a:lstStyle/>
-          <a:p>
-            <a:pPr algn="ctr"/>
-          </a:p>
-        </p:txBody>
-      </p:sp>
-      <p:sp>
-        <p:nvSpPr>
-          <p:cNvPr id="36" name="Rounded Rectangle 35"/>
-          <p:cNvSpPr/>
-          <p:nvPr/>
-        </p:nvSpPr>
-        <p:spPr>
-          <a:xfrm>
-            <a:off x="502920" y="5961888"/>
-            <a:ext cx="11155680" cy="109728"/>
-          </a:xfrm>
-          <a:prstGeom prst="roundRect">
-            <a:avLst>
-              <a:gd name="adj" fmla="val 50000"/>
-            </a:avLst>
-          </a:prstGeom>
-          <a:solidFill>
-            <a:srgbClr val="D4A853"/>
-          </a:solidFill>
-          <a:ln>
-            <a:noFill/>
-          </a:ln>
-        </p:spPr>
-        <p:style>
-          <a:lnRef idx="1">
-            <a:schemeClr val="accent1"/>
-          </a:lnRef>
-          <a:fillRef idx="3">
-            <a:schemeClr val="accent1"/>
-          </a:fillRef>
-          <a:effectRef idx="2">
-            <a:schemeClr val="accent1"/>
-          </a:effectRef>
-          <a:fontRef idx="minor">
-            <a:schemeClr val="lt1"/>
-          </a:fontRef>
-        </p:style>
-        <p:txBody>
-          <a:bodyPr rtlCol="0" anchor="ctr"/>
-          <a:lstStyle/>
-          <a:p>
-            <a:pPr algn="ctr"/>
-          </a:p>
-        </p:txBody>
-      </p:sp>
-      <p:sp>
-        <p:nvSpPr>
-          <p:cNvPr id="37" name="TextBox 36"/>
-          <p:cNvSpPr txBox="1"/>
-          <p:nvPr/>
-        </p:nvSpPr>
-        <p:spPr>
-          <a:xfrm>
-            <a:off x="502920" y="5760720"/>
-            <a:ext cx="5029200" cy="201168"/>
-          </a:xfrm>
-          <a:prstGeom prst="rect">
-            <a:avLst/>
-          </a:prstGeom>
-          <a:noFill/>
-        </p:spPr>
-        <p:txBody>
-          <a:bodyPr wrap="none">
-            <a:spAutoFit/>
-          </a:bodyPr>
-          <a:lstStyle/>
-          <a:p>
-            <a:pPr algn="l">
-              <a:spcAft>
-                <a:spcPts val="0"/>
-              </a:spcAft>
-            </a:pPr>
-            <a:r>
-              <a:rPr sz="800" b="0">
-                <a:solidFill>
-                  <a:srgbClr val="8B9CB3"/>
-                </a:solidFill>
-                <a:latin typeface="Calibri"/>
-              </a:rPr>
-              <a:t>Countdown starts in Slideshow · red MOVE ON appears when budget ends · does not auto-advance</a:t>
-            </a:r>
-          </a:p>
-        </p:txBody>
-      </p:sp>
-      <p:sp>
-        <p:nvSpPr>
-          <p:cNvPr id="38" name="Rounded Rectangle 37"/>
-          <p:cNvSpPr/>
-          <p:nvPr/>
-        </p:nvSpPr>
-        <p:spPr>
-          <a:xfrm>
-            <a:off x="9189720" y="5614416"/>
-            <a:ext cx="2468880" cy="292608"/>
-          </a:xfrm>
-          <a:prstGeom prst="roundRect">
-            <a:avLst>
-              <a:gd name="adj" fmla="val 20000"/>
-            </a:avLst>
-          </a:prstGeom>
-          <a:solidFill>
-            <a:srgbClr val="F87171"/>
-          </a:solidFill>
-          <a:ln>
-            <a:noFill/>
-          </a:ln>
-        </p:spPr>
-        <p:style>
-          <a:lnRef idx="1">
-            <a:schemeClr val="accent1"/>
-          </a:lnRef>
-          <a:fillRef idx="3">
-            <a:schemeClr val="accent1"/>
-          </a:fillRef>
-          <a:effectRef idx="2">
-            <a:schemeClr val="accent1"/>
-          </a:effectRef>
-          <a:fontRef idx="minor">
-            <a:schemeClr val="lt1"/>
-          </a:fontRef>
-        </p:style>
-        <p:txBody>
-          <a:bodyPr rtlCol="0" anchor="ctr" wrap="none"/>
-          <a:lstStyle/>
-          <a:p>
-            <a:pPr algn="ctr"/>
-            <a:r>
-              <a:rPr sz="1200" b="1">
-                <a:solidFill>
-                  <a:srgbClr val="E6EDF3"/>
-                </a:solidFill>
-                <a:latin typeface="Calibri"/>
-              </a:rPr>
-              <a:t>MOVE ON  →</a:t>
-            </a:r>
-          </a:p>
-        </p:txBody>
-      </p:sp>
     </p:spTree>
   </p:cSld>
   <p:clrMapOvr>
     <a:masterClrMapping/>
   </p:clrMapOvr>
-  <p:timing>
-    <p:tnLst>
-      <p:par>
-        <p:cTn id="1" dur="indefinite" restart="never" nodeType="tmRoot">
-          <p:childTnLst>
-            <p:seq concurrent="1" nextAc="seek">
-              <p:cTn id="2" dur="indefinite" nodeType="mainSeq">
-                <p:childTnLst>
-                  <p:par>
-                    <p:cTn id="3" fill="hold">
-                      <p:stCondLst>
-                        <p:cond delay="0"/>
-                      </p:stCondLst>
-                      <p:childTnLst>
-                        <p:par>
-                          <p:cTn id="4" fill="hold">
-                            <p:stCondLst>
-                              <p:cond delay="0"/>
-                            </p:stCondLst>
-                            <p:childTnLst>
-                              <p:set>
-                                <p:cBhvr>
-                                  <p:cTn id="5" dur="1" fill="hold"/>
-                                  <p:tgtEl>
-                                    <p:spTgt spid="38"/>
-                                  </p:tgtEl>
-                                  <p:attrNameLst>
-                                    <p:attrName>style.visibility</p:attrName>
-                                  </p:attrNameLst>
-                                </p:cBhvr>
-                                <p:to>
-                                  <p:strVal val="hidden"/>
-                                </p:to>
-                              </p:set>
-                              <p:animEffect transition="out" filter="wipe(left)">
-                                <p:cBhvr>
-                                  <p:cTn id="6" dur="75000" fill="hold"/>
-                                  <p:tgtEl>
-                                    <p:spTgt spid="36"/>
-                                  </p:tgtEl>
-                                </p:cBhvr>
-                              </p:animEffect>
-                              <p:animEffect transition="in" filter="fade">
-                                <p:cBhvr>
-                                  <p:cTn id="7" dur="400" fill="hold">
-                                    <p:stCondLst>
-                                      <p:cond delay="75000"/>
-                                    </p:stCondLst>
-                                  </p:cTn>
-                                  <p:tgtEl>
-                                    <p:spTgt spid="38"/>
-                                  </p:tgtEl>
-                                </p:cBhvr>
-                              </p:animEffect>
-                              <p:set>
-                                <p:cBhvr>
-                                  <p:cTn id="8" dur="1" fill="hold">
-                                    <p:stCondLst>
-                                      <p:cond delay="75000"/>
-                                    </p:stCondLst>
-                                  </p:cTn>
-                                  <p:tgtEl>
-                                    <p:spTgt spid="38"/>
-                                  </p:tgtEl>
-                                  <p:attrNameLst>
-                                    <p:attrName>style.visibility</p:attrName>
-                                  </p:attrNameLst>
-                                </p:cBhvr>
-                                <p:to>
-                                  <p:strVal val="visible"/>
-                                </p:to>
-                              </p:set>
-                            </p:childTnLst>
-                          </p:cTn>
-                        </p:par>
-                      </p:childTnLst>
-                    </p:cTn>
-                  </p:par>
-                </p:childTnLst>
-              </p:cTn>
-              <p:prevCondLst>
-                <p:cond evt="onPrev" delay="0">
-                  <p:tgtEl>
-                    <p:sldTgt/>
-                  </p:tgtEl>
-                </p:cond>
-              </p:prevCondLst>
-              <p:nextCondLst>
-                <p:cond evt="onNext" delay="0">
-                  <p:tgtEl>
-                    <p:sldTgt/>
-                  </p:tgtEl>
-                </p:cond>
-              </p:nextCondLst>
-            </p:seq>
-          </p:childTnLst>
-        </p:cTn>
-      </p:par>
-    </p:tnLst>
-  </p:timing>
 </p:sld>
 </file>
 

</xml_diff>